<commit_message>
docs: refine transition model presentation
</commit_message>
<xml_diff>
--- a/outputs/SmartPitch_TransitionModels_Presentation.pptx
+++ b/outputs/SmartPitch_TransitionModels_Presentation.pptx
@@ -3980,7 +3980,7 @@
                 </a:solidFill>
               </a:rPr>
               <a:t>arsenal 58d 추가 → LR +21pp, LGB +54pp, MLP +27pp
-MLP 27K params = Transformer 9.7M params (context 있을 때)</a:t>
+Top-1은 sequence baseline과 유사, MDP 호환성이 강점</a:t>
             </a:r>
           </a:p>
         </p:txBody>
@@ -4171,7 +4171,7 @@
                   <a:srgbClr val="E67E22"/>
                 </a:solidFill>
               </a:rPr>
-              <a:t>rl-agent 통합</a:t>
+              <a:t>rl-agent 사용 방식</a:t>
             </a:r>
           </a:p>
         </p:txBody>
@@ -4200,20 +4200,19 @@
           <a:p>
             <a:pPr algn="l"/>
             <a:r>
-              <a:rPr sz="900" b="0">
+              <a:rPr sz="880" b="0">
                 <a:solidFill>
                   <a:srgbClr val="FFFFFF"/>
                 </a:solidFill>
               </a:rPr>
-              <a:t>from src.inference.transition_model import (
-    TransitionModelMLP10,
-    build_135dim_feature
-)
-model = TransitionModelMLP10(
-    'outputs/checkpoints/...best.pt'
-)
-x = build_135dim_feature(pitch, arsenal)
-probs = model.predict(x)  # shape (10,)</a:t>
+              <a:t>MDP-VI
+  P(s'|s,a) table 직접 precompute
+Dyna-Q
+  planning에서 transition cache 사용
+DQN / DDQN / PPO
+  전이표 직접 사용 X
+  PitchEnv.step()이 MLP10/MLP10H로
+  outcome을 샘플링</a:t>
             </a:r>
           </a:p>
         </p:txBody>
@@ -4281,7 +4280,7 @@
                   <a:srgbClr val="2C3E50"/>
                 </a:solidFill>
               </a:rPr>
-              <a:t>• 타자 arsenal feature → Single~HR 0% 해결</a:t>
+              <a:t>• MLP10H RL 비교 강화 → BIP 보상 안정화</a:t>
             </a:r>
           </a:p>
         </p:txBody>
@@ -4315,7 +4314,7 @@
                   <a:srgbClr val="2C3E50"/>
                 </a:solidFill>
               </a:rPr>
-              <a:t>• Small Transformer (2-layer) MDP 호환 탐색</a:t>
+              <a:t>• 타자 arsenal feature → Single~HR 0% 해결</a:t>
             </a:r>
           </a:p>
         </p:txBody>
@@ -4349,7 +4348,41 @@
                   <a:srgbClr val="2C3E50"/>
                 </a:solidFill>
               </a:rPr>
-              <a:t>• UMAP 0-fill ablation (50% dropout)</a:t>
+              <a:t>• Small Transformer (2-layer) MDP 호환 탐색</a:t>
+            </a:r>
+          </a:p>
+        </p:txBody>
+      </p:sp>
+      <p:sp>
+        <p:nvSpPr>
+          <p:cNvPr id="21" name="TextBox 20"/>
+          <p:cNvSpPr txBox="1"/>
+          <p:nvPr/>
+        </p:nvSpPr>
+        <p:spPr>
+          <a:xfrm>
+            <a:off x="504000" y="3203997"/>
+            <a:ext cx="6703923" cy="180000"/>
+          </a:xfrm>
+          <a:prstGeom prst="rect">
+            <a:avLst/>
+          </a:prstGeom>
+          <a:noFill/>
+        </p:spPr>
+        <p:txBody>
+          <a:bodyPr wrap="square">
+            <a:spAutoFit/>
+          </a:bodyPr>
+          <a:lstStyle/>
+          <a:p>
+            <a:pPr algn="l"/>
+            <a:r>
+              <a:rPr sz="1050" b="0">
+                <a:solidFill>
+                  <a:srgbClr val="2C3E50"/>
+                </a:solidFill>
+              </a:rPr>
+              <a:t>• UMAP 0-fill ablation</a:t>
             </a:r>
           </a:p>
         </p:txBody>
@@ -4940,7 +4973,7 @@
                   <a:srgbClr val="2980B9"/>
                 </a:solidFill>
               </a:rPr>
-              <a:t>① 공정 비교</a:t>
+              <a:t>① 비교 조건 분리</a:t>
             </a:r>
           </a:p>
         </p:txBody>
@@ -4974,7 +5007,7 @@
                   <a:srgbClr val="2C3E50"/>
                 </a:solidFill>
               </a:rPr>
-              <a:t>동일 데이터·지표로 두 논문 비교</a:t>
+              <a:t>같은 N·지표끼리만 직접 비교</a:t>
             </a:r>
           </a:p>
         </p:txBody>
@@ -5395,7 +5428,7 @@
                   <a:srgbClr val="E67E22"/>
                 </a:solidFill>
               </a:rPr>
-              <a:t>차별점: Otremba MDP/RL 통합  +  MIT Sloan 10-class 세분화  +  본인 Arsenal Context 58d</a:t>
+              <a:t>차별점: Otremba MDP/RL 통합  +  MIT Sloan-style 10-class 세분화  +  본인 Arsenal Context 58d</a:t>
             </a:r>
           </a:p>
         </p:txBody>
@@ -11448,7 +11481,7 @@
                   <a:srgbClr val="FFFFFF"/>
                 </a:solidFill>
               </a:rPr>
-              <a:t>SOTA 비교: 객관적 위치</a:t>
+              <a:t>베이스라인 비교: 객관적 위치</a:t>
             </a:r>
           </a:p>
         </p:txBody>
@@ -11540,7 +11573,7 @@
                   <a:srgbClr val="E67E22"/>
                 </a:solidFill>
               </a:rPr>
-              <a:t>※ 10-class 동일 task 기준: LLM 64.0% &lt; MIT Sloan 67.2% ≈ 본인 67.6% (MDP 호환 추가)</a:t>
+              <a:t>직접 주장 가능한 비교: 내부 Transformer baseline 67.2% vs MLP10 67.6%; 외부 문헌은 참고용</a:t>
             </a:r>
           </a:p>
         </p:txBody>
@@ -13011,7 +13044,7 @@
                 </a:solidFill>
               </a:rPr>
               <a:t>결론: Collapse 원인 = Architecture × Feature 수 아님 = 투수 맥락(pitcher context) 부재
-MLP 27K params ≈ Transformer 9.7M params (context 있을 때) — 360배 파라미터 효율</a:t>
+Top-1은 sequence baseline과 유사, MLP10은 MDP 호환성과 추론 효율이 강점</a:t>
             </a:r>
           </a:p>
         </p:txBody>
@@ -13251,7 +13284,7 @@
                   <a:srgbClr val="27AE60"/>
                 </a:solidFill>
               </a:rPr>
-              <a:t>✅ 최종 권장: TransitionModelMLP10</a:t>
+              <a:t>✅ 최종 모델: TransitionModelMLP10 / RL 권장 경로: MLP10H</a:t>
             </a:r>
           </a:p>
         </p:txBody>
@@ -13280,12 +13313,13 @@
           <a:p>
             <a:pPr algn="l"/>
             <a:r>
-              <a:rPr sz="1050" b="0">
+              <a:rPr sz="980" b="0">
                 <a:solidFill>
                   <a:srgbClr val="2C3E50"/>
                 </a:solidFill>
               </a:rPr>
-              <a:t>입력: 135d (단일 pitch) | Top-1: 67.6% | Macro-F1: 27.8% | CE: 0.926 | Params: ~32K | 추론: &lt;1ms | MDP 호환: ✅</a:t>
+              <a:t>MLP10: 135d 단일 pitch, Top-1 67.6%, Macro-F1 27.8%, CE 0.926, MDP 호환
+MLP10H: MLP10의 BIP 총량을 empirical BIP table로 재분배해 Single~HR 0% 문제 완화</a:t>
             </a:r>
           </a:p>
         </p:txBody>

</xml_diff>

<commit_message>
feat(presentation): add full 4-repo pipeline PPT + ratio fix + redesigned baseline comparison
- scripts/42_build_fullpipeline_figures.py: pipeline 4-stage diagram + RL reward comparison chart
- scripts/43_build_fullpipeline_pptx.py: 10-slide presentation covering all 4 repos (data/clustering/transition-models/rl-agent) with folder tag chips
- outputs/SmartPitch_FullPipeline_Presentation.pptx: final 10-slide deck (830 KB)
- scripts/41_build_pptx.py: add add_image_fit() letterbox helper (PIL-based ratio preservation)
- scripts/40_build_presentation_figures.py: redesign fig4 as honest 4-bar baseline ladder (JSON-sourced values)
- outputs/SmartPitch_TransitionModels_Presentation.pptx: rebuilt with correct aspect ratios (no more squish)
- docs/presentation_slides.md: refine SOTA framing, MDP-VI/Dyna-Q direct vs DQN/PPO indirect

Co-Authored-By: Claude Opus 4.7 <noreply@anthropic.com>
</commit_message>
<xml_diff>
--- a/outputs/SmartPitch_TransitionModels_Presentation.pptx
+++ b/outputs/SmartPitch_TransitionModels_Presentation.pptx
@@ -3357,7 +3357,7 @@
                 </a:solidFill>
               </a:rPr>
               <a:t>MLB Statcast 2022–2024
-2,983,621 투구</a:t>
+2,233,284 train/val/test</a:t>
             </a:r>
           </a:p>
         </p:txBody>
@@ -5676,7 +5676,7 @@
                   <a:srgbClr val="2C3E50"/>
                 </a:solidFill>
               </a:rPr>
-              <a:t>2022 · 2023 · 2024 (3시즌)</a:t>
+              <a:t>2022 · 2023 · 2024</a:t>
             </a:r>
           </a:p>
         </p:txBody>
@@ -5753,7 +5753,7 @@
                   <a:srgbClr val="2980B9"/>
                 </a:solidFill>
               </a:rPr>
-              <a:t>총 투구 수</a:t>
+              <a:t>학습/평가</a:t>
             </a:r>
           </a:p>
         </p:txBody>
@@ -5787,7 +5787,7 @@
                   <a:srgbClr val="2C3E50"/>
                 </a:solidFill>
               </a:rPr>
-              <a:t>2,983,621 rows</a:t>
+              <a:t>2,233,284 rows</a:t>
             </a:r>
           </a:p>
         </p:txBody>
@@ -5864,7 +5864,7 @@
                   <a:srgbClr val="2980B9"/>
                 </a:solidFill>
               </a:rPr>
-              <a:t>Test set</a:t>
+              <a:t>Split</a:t>
             </a:r>
           </a:p>
         </p:txBody>
@@ -5898,7 +5898,7 @@
                   <a:srgbClr val="2C3E50"/>
                 </a:solidFill>
               </a:rPr>
-              <a:t>353,667–353,776 (2024 H2)</a:t>
+              <a:t>1,494,188 / 385,320 / 353,776</a:t>
             </a:r>
           </a:p>
         </p:txBody>
@@ -5975,7 +5975,7 @@
                   <a:srgbClr val="2980B9"/>
                 </a:solidFill>
               </a:rPr>
-              <a:t>Feature</a:t>
+              <a:t>handoff pool</a:t>
             </a:r>
           </a:p>
         </p:txBody>
@@ -6009,6 +6009,117 @@
                   <a:srgbClr val="2C3E50"/>
                 </a:solidFill>
               </a:rPr>
+              <a:t>2,983,621 source rows</a:t>
+            </a:r>
+          </a:p>
+        </p:txBody>
+      </p:sp>
+      <p:sp>
+        <p:nvSpPr>
+          <p:cNvPr id="17" name="Rectangle 16"/>
+          <p:cNvSpPr/>
+          <p:nvPr/>
+        </p:nvSpPr>
+        <p:spPr>
+          <a:xfrm>
+            <a:off x="432000" y="2088000"/>
+            <a:ext cx="1980000" cy="251999"/>
+          </a:xfrm>
+          <a:prstGeom prst="rect">
+            <a:avLst/>
+          </a:prstGeom>
+          <a:solidFill>
+            <a:srgbClr val="F8F9FA"/>
+          </a:solidFill>
+          <a:ln>
+            <a:noFill/>
+          </a:ln>
+        </p:spPr>
+        <p:style>
+          <a:lnRef idx="1">
+            <a:schemeClr val="accent1"/>
+          </a:lnRef>
+          <a:fillRef idx="3">
+            <a:schemeClr val="accent1"/>
+          </a:fillRef>
+          <a:effectRef idx="2">
+            <a:schemeClr val="accent1"/>
+          </a:effectRef>
+          <a:fontRef idx="minor">
+            <a:schemeClr val="lt1"/>
+          </a:fontRef>
+        </p:style>
+        <p:txBody>
+          <a:bodyPr rtlCol="0" anchor="ctr"/>
+          <a:lstStyle/>
+          <a:p>
+            <a:pPr algn="ctr"/>
+          </a:p>
+        </p:txBody>
+      </p:sp>
+      <p:sp>
+        <p:nvSpPr>
+          <p:cNvPr id="18" name="TextBox 17"/>
+          <p:cNvSpPr txBox="1"/>
+          <p:nvPr/>
+        </p:nvSpPr>
+        <p:spPr>
+          <a:xfrm>
+            <a:off x="504000" y="2124000"/>
+            <a:ext cx="720000" cy="198000"/>
+          </a:xfrm>
+          <a:prstGeom prst="rect">
+            <a:avLst/>
+          </a:prstGeom>
+          <a:noFill/>
+        </p:spPr>
+        <p:txBody>
+          <a:bodyPr wrap="square">
+            <a:spAutoFit/>
+          </a:bodyPr>
+          <a:lstStyle/>
+          <a:p>
+            <a:pPr algn="l"/>
+            <a:r>
+              <a:rPr sz="1100" b="1">
+                <a:solidFill>
+                  <a:srgbClr val="2980B9"/>
+                </a:solidFill>
+              </a:rPr>
+              <a:t>Feature</a:t>
+            </a:r>
+          </a:p>
+        </p:txBody>
+      </p:sp>
+      <p:sp>
+        <p:nvSpPr>
+          <p:cNvPr id="19" name="TextBox 18"/>
+          <p:cNvSpPr txBox="1"/>
+          <p:nvPr/>
+        </p:nvSpPr>
+        <p:spPr>
+          <a:xfrm>
+            <a:off x="1259999" y="2124000"/>
+            <a:ext cx="1080000" cy="198000"/>
+          </a:xfrm>
+          <a:prstGeom prst="rect">
+            <a:avLst/>
+          </a:prstGeom>
+          <a:noFill/>
+        </p:spPr>
+        <p:txBody>
+          <a:bodyPr wrap="square">
+            <a:spAutoFit/>
+          </a:bodyPr>
+          <a:lstStyle/>
+          <a:p>
+            <a:pPr algn="l"/>
+            <a:r>
+              <a:rPr sz="1100" b="0">
+                <a:solidFill>
+                  <a:srgbClr val="2C3E50"/>
+                </a:solidFill>
+              </a:rPr>
               <a:t>77d / 87d / 135d</a:t>
             </a:r>
           </a:p>
@@ -6016,7 +6127,7 @@
       </p:sp>
       <p:sp>
         <p:nvSpPr>
-          <p:cNvPr id="17" name="Rectangle 16"/>
+          <p:cNvPr id="20" name="Rectangle 19"/>
           <p:cNvSpPr/>
           <p:nvPr/>
         </p:nvSpPr>
@@ -6061,7 +6172,7 @@
       </p:sp>
       <p:sp>
         <p:nvSpPr>
-          <p:cNvPr id="18" name="TextBox 17"/>
+          <p:cNvPr id="21" name="TextBox 20"/>
           <p:cNvSpPr txBox="1"/>
           <p:nvPr/>
         </p:nvSpPr>
@@ -6095,7 +6206,7 @@
       </p:sp>
       <p:sp>
         <p:nvSpPr>
-          <p:cNvPr id="19" name="TextBox 18"/>
+          <p:cNvPr id="22" name="TextBox 21"/>
           <p:cNvSpPr txBox="1"/>
           <p:nvPr/>
         </p:nvSpPr>
@@ -6130,7 +6241,7 @@
       </p:sp>
       <p:sp>
         <p:nvSpPr>
-          <p:cNvPr id="20" name="Rectangle 19"/>
+          <p:cNvPr id="23" name="Rectangle 22"/>
           <p:cNvSpPr/>
           <p:nvPr/>
         </p:nvSpPr>
@@ -6175,7 +6286,7 @@
       </p:sp>
       <p:sp>
         <p:nvSpPr>
-          <p:cNvPr id="21" name="TextBox 20"/>
+          <p:cNvPr id="24" name="TextBox 23"/>
           <p:cNvSpPr txBox="1"/>
           <p:nvPr/>
         </p:nvSpPr>
@@ -6209,7 +6320,7 @@
       </p:sp>
       <p:sp>
         <p:nvSpPr>
-          <p:cNvPr id="22" name="TextBox 21"/>
+          <p:cNvPr id="25" name="TextBox 24"/>
           <p:cNvSpPr txBox="1"/>
           <p:nvPr/>
         </p:nvSpPr>
@@ -6243,7 +6354,7 @@
       </p:sp>
       <p:sp>
         <p:nvSpPr>
-          <p:cNvPr id="23" name="Rectangle 22"/>
+          <p:cNvPr id="26" name="Rectangle 25"/>
           <p:cNvSpPr/>
           <p:nvPr/>
         </p:nvSpPr>
@@ -6288,7 +6399,7 @@
       </p:sp>
       <p:sp>
         <p:nvSpPr>
-          <p:cNvPr id="24" name="TextBox 23"/>
+          <p:cNvPr id="27" name="TextBox 26"/>
           <p:cNvSpPr txBox="1"/>
           <p:nvPr/>
         </p:nvSpPr>
@@ -6322,7 +6433,7 @@
       </p:sp>
       <p:sp>
         <p:nvSpPr>
-          <p:cNvPr id="25" name="TextBox 24"/>
+          <p:cNvPr id="28" name="TextBox 27"/>
           <p:cNvSpPr txBox="1"/>
           <p:nvPr/>
         </p:nvSpPr>
@@ -6356,13 +6467,13 @@
       </p:sp>
       <p:sp>
         <p:nvSpPr>
-          <p:cNvPr id="26" name="Rectangle 25"/>
+          <p:cNvPr id="29" name="Rectangle 28"/>
           <p:cNvSpPr/>
           <p:nvPr/>
         </p:nvSpPr>
         <p:spPr>
           <a:xfrm>
-            <a:off x="432000" y="2196000"/>
+            <a:off x="432000" y="2502000"/>
             <a:ext cx="11324952" cy="360000"/>
           </a:xfrm>
           <a:prstGeom prst="rect">
@@ -6399,13 +6510,13 @@
       </p:sp>
       <p:sp>
         <p:nvSpPr>
-          <p:cNvPr id="27" name="TextBox 26"/>
-          <p:cNvSpPr txBox="1"/>
-          <p:nvPr/>
-        </p:nvSpPr>
-        <p:spPr>
-          <a:xfrm>
-            <a:off x="540000" y="2213999"/>
+          <p:cNvPr id="30" name="TextBox 29"/>
+          <p:cNvSpPr txBox="1"/>
+          <p:nvPr/>
+        </p:nvSpPr>
+        <p:spPr>
+          <a:xfrm>
+            <a:off x="540000" y="2519999"/>
             <a:ext cx="1800000" cy="162000"/>
           </a:xfrm>
           <a:prstGeom prst="rect">
@@ -6433,13 +6544,13 @@
       </p:sp>
       <p:sp>
         <p:nvSpPr>
-          <p:cNvPr id="28" name="TextBox 27"/>
-          <p:cNvSpPr txBox="1"/>
-          <p:nvPr/>
-        </p:nvSpPr>
-        <p:spPr>
-          <a:xfrm>
-            <a:off x="540000" y="2286000"/>
+          <p:cNvPr id="31" name="TextBox 30"/>
+          <p:cNvSpPr txBox="1"/>
+          <p:nvPr/>
+        </p:nvSpPr>
+        <p:spPr>
+          <a:xfrm>
+            <a:off x="540000" y="2592000"/>
             <a:ext cx="11108952" cy="251999"/>
           </a:xfrm>
           <a:prstGeom prst="rect">
@@ -11536,8 +11647,8 @@
         </p:blipFill>
         <p:spPr>
           <a:xfrm>
-            <a:off x="432000" y="756000"/>
-            <a:ext cx="11324952" cy="5052050"/>
+            <a:off x="488700" y="756000"/>
+            <a:ext cx="11211552" cy="5634000"/>
           </a:xfrm>
           <a:prstGeom prst="rect">
             <a:avLst/>
@@ -11731,8 +11842,8 @@
         </p:blipFill>
         <p:spPr>
           <a:xfrm>
-            <a:off x="432000" y="756000"/>
-            <a:ext cx="11324952" cy="1368000"/>
+            <a:off x="3948876" y="756000"/>
+            <a:ext cx="4291200" cy="1584000"/>
           </a:xfrm>
           <a:prstGeom prst="rect">
             <a:avLst/>
@@ -11747,7 +11858,7 @@
         </p:nvSpPr>
         <p:spPr>
           <a:xfrm>
-            <a:off x="432000" y="2196000"/>
+            <a:off x="432000" y="2411999"/>
             <a:ext cx="2473489" cy="198000"/>
           </a:xfrm>
           <a:prstGeom prst="rect">
@@ -11790,7 +11901,7 @@
         </p:nvSpPr>
         <p:spPr>
           <a:xfrm>
-            <a:off x="468000" y="2214000"/>
+            <a:off x="468000" y="2429999"/>
             <a:ext cx="2419489" cy="162000"/>
           </a:xfrm>
           <a:prstGeom prst="rect">
@@ -11824,7 +11935,7 @@
         </p:nvSpPr>
         <p:spPr>
           <a:xfrm>
-            <a:off x="2923489" y="2196000"/>
+            <a:off x="2923489" y="2411999"/>
             <a:ext cx="2473489" cy="198000"/>
           </a:xfrm>
           <a:prstGeom prst="rect">
@@ -11867,7 +11978,7 @@
         </p:nvSpPr>
         <p:spPr>
           <a:xfrm>
-            <a:off x="2959489" y="2214000"/>
+            <a:off x="2959489" y="2429999"/>
             <a:ext cx="2419489" cy="162000"/>
           </a:xfrm>
           <a:prstGeom prst="rect">
@@ -11901,7 +12012,7 @@
         </p:nvSpPr>
         <p:spPr>
           <a:xfrm>
-            <a:off x="5414978" y="2196000"/>
+            <a:off x="5414978" y="2411999"/>
             <a:ext cx="2473489" cy="198000"/>
           </a:xfrm>
           <a:prstGeom prst="rect">
@@ -11944,7 +12055,7 @@
         </p:nvSpPr>
         <p:spPr>
           <a:xfrm>
-            <a:off x="5450978" y="2214000"/>
+            <a:off x="5450978" y="2429999"/>
             <a:ext cx="2419489" cy="162000"/>
           </a:xfrm>
           <a:prstGeom prst="rect">
@@ -11978,7 +12089,7 @@
         </p:nvSpPr>
         <p:spPr>
           <a:xfrm>
-            <a:off x="7906468" y="2196000"/>
+            <a:off x="7906468" y="2411999"/>
             <a:ext cx="2020491" cy="198000"/>
           </a:xfrm>
           <a:prstGeom prst="rect">
@@ -12021,7 +12132,7 @@
         </p:nvSpPr>
         <p:spPr>
           <a:xfrm>
-            <a:off x="7942468" y="2214000"/>
+            <a:off x="7942468" y="2429999"/>
             <a:ext cx="1966491" cy="162000"/>
           </a:xfrm>
           <a:prstGeom prst="rect">
@@ -12055,7 +12166,7 @@
         </p:nvSpPr>
         <p:spPr>
           <a:xfrm>
-            <a:off x="432000" y="2394000"/>
+            <a:off x="432000" y="2609999"/>
             <a:ext cx="2473489" cy="198000"/>
           </a:xfrm>
           <a:prstGeom prst="rect">
@@ -12098,7 +12209,7 @@
         </p:nvSpPr>
         <p:spPr>
           <a:xfrm>
-            <a:off x="468000" y="2412000"/>
+            <a:off x="468000" y="2627999"/>
             <a:ext cx="2419489" cy="162000"/>
           </a:xfrm>
           <a:prstGeom prst="rect">
@@ -12132,7 +12243,7 @@
         </p:nvSpPr>
         <p:spPr>
           <a:xfrm>
-            <a:off x="2923489" y="2394000"/>
+            <a:off x="2923489" y="2609999"/>
             <a:ext cx="2473489" cy="198000"/>
           </a:xfrm>
           <a:prstGeom prst="rect">
@@ -12175,7 +12286,7 @@
         </p:nvSpPr>
         <p:spPr>
           <a:xfrm>
-            <a:off x="2959489" y="2412000"/>
+            <a:off x="2959489" y="2627999"/>
             <a:ext cx="2419489" cy="162000"/>
           </a:xfrm>
           <a:prstGeom prst="rect">
@@ -12209,7 +12320,7 @@
         </p:nvSpPr>
         <p:spPr>
           <a:xfrm>
-            <a:off x="5414978" y="2394000"/>
+            <a:off x="5414978" y="2609999"/>
             <a:ext cx="2473489" cy="198000"/>
           </a:xfrm>
           <a:prstGeom prst="rect">
@@ -12252,7 +12363,7 @@
         </p:nvSpPr>
         <p:spPr>
           <a:xfrm>
-            <a:off x="5450978" y="2412000"/>
+            <a:off x="5450978" y="2627999"/>
             <a:ext cx="2419489" cy="162000"/>
           </a:xfrm>
           <a:prstGeom prst="rect">
@@ -12286,7 +12397,7 @@
         </p:nvSpPr>
         <p:spPr>
           <a:xfrm>
-            <a:off x="7906468" y="2394000"/>
+            <a:off x="7906468" y="2609999"/>
             <a:ext cx="2020491" cy="198000"/>
           </a:xfrm>
           <a:prstGeom prst="rect">
@@ -12329,7 +12440,7 @@
         </p:nvSpPr>
         <p:spPr>
           <a:xfrm>
-            <a:off x="7942468" y="2412000"/>
+            <a:off x="7942468" y="2627999"/>
             <a:ext cx="1966491" cy="162000"/>
           </a:xfrm>
           <a:prstGeom prst="rect">
@@ -12363,7 +12474,7 @@
         </p:nvSpPr>
         <p:spPr>
           <a:xfrm>
-            <a:off x="432000" y="2592000"/>
+            <a:off x="432000" y="2807999"/>
             <a:ext cx="2473489" cy="198000"/>
           </a:xfrm>
           <a:prstGeom prst="rect">
@@ -12406,7 +12517,7 @@
         </p:nvSpPr>
         <p:spPr>
           <a:xfrm>
-            <a:off x="468000" y="2610000"/>
+            <a:off x="468000" y="2825999"/>
             <a:ext cx="2419489" cy="162000"/>
           </a:xfrm>
           <a:prstGeom prst="rect">
@@ -12440,7 +12551,7 @@
         </p:nvSpPr>
         <p:spPr>
           <a:xfrm>
-            <a:off x="2923489" y="2592000"/>
+            <a:off x="2923489" y="2807999"/>
             <a:ext cx="2473489" cy="198000"/>
           </a:xfrm>
           <a:prstGeom prst="rect">
@@ -12483,7 +12594,7 @@
         </p:nvSpPr>
         <p:spPr>
           <a:xfrm>
-            <a:off x="2959489" y="2610000"/>
+            <a:off x="2959489" y="2825999"/>
             <a:ext cx="2419489" cy="162000"/>
           </a:xfrm>
           <a:prstGeom prst="rect">
@@ -12517,7 +12628,7 @@
         </p:nvSpPr>
         <p:spPr>
           <a:xfrm>
-            <a:off x="5414978" y="2592000"/>
+            <a:off x="5414978" y="2807999"/>
             <a:ext cx="2473489" cy="198000"/>
           </a:xfrm>
           <a:prstGeom prst="rect">
@@ -12560,7 +12671,7 @@
         </p:nvSpPr>
         <p:spPr>
           <a:xfrm>
-            <a:off x="5450978" y="2610000"/>
+            <a:off x="5450978" y="2825999"/>
             <a:ext cx="2419489" cy="162000"/>
           </a:xfrm>
           <a:prstGeom prst="rect">
@@ -12594,7 +12705,7 @@
         </p:nvSpPr>
         <p:spPr>
           <a:xfrm>
-            <a:off x="7906468" y="2592000"/>
+            <a:off x="7906468" y="2807999"/>
             <a:ext cx="2020491" cy="198000"/>
           </a:xfrm>
           <a:prstGeom prst="rect">
@@ -12637,7 +12748,7 @@
         </p:nvSpPr>
         <p:spPr>
           <a:xfrm>
-            <a:off x="7942468" y="2610000"/>
+            <a:off x="7942468" y="2825999"/>
             <a:ext cx="1966491" cy="162000"/>
           </a:xfrm>
           <a:prstGeom prst="rect">
@@ -12671,7 +12782,7 @@
         </p:nvSpPr>
         <p:spPr>
           <a:xfrm>
-            <a:off x="432000" y="2790000"/>
+            <a:off x="432000" y="3005999"/>
             <a:ext cx="2473489" cy="198000"/>
           </a:xfrm>
           <a:prstGeom prst="rect">
@@ -12714,7 +12825,7 @@
         </p:nvSpPr>
         <p:spPr>
           <a:xfrm>
-            <a:off x="468000" y="2808000"/>
+            <a:off x="468000" y="3023999"/>
             <a:ext cx="2419489" cy="162000"/>
           </a:xfrm>
           <a:prstGeom prst="rect">
@@ -12748,7 +12859,7 @@
         </p:nvSpPr>
         <p:spPr>
           <a:xfrm>
-            <a:off x="2923489" y="2790000"/>
+            <a:off x="2923489" y="3005999"/>
             <a:ext cx="2473489" cy="198000"/>
           </a:xfrm>
           <a:prstGeom prst="rect">
@@ -12791,7 +12902,7 @@
         </p:nvSpPr>
         <p:spPr>
           <a:xfrm>
-            <a:off x="2959489" y="2808000"/>
+            <a:off x="2959489" y="3023999"/>
             <a:ext cx="2419489" cy="162000"/>
           </a:xfrm>
           <a:prstGeom prst="rect">
@@ -12825,7 +12936,7 @@
         </p:nvSpPr>
         <p:spPr>
           <a:xfrm>
-            <a:off x="5414978" y="2790000"/>
+            <a:off x="5414978" y="3005999"/>
             <a:ext cx="2473489" cy="198000"/>
           </a:xfrm>
           <a:prstGeom prst="rect">
@@ -12868,7 +12979,7 @@
         </p:nvSpPr>
         <p:spPr>
           <a:xfrm>
-            <a:off x="5450978" y="2808000"/>
+            <a:off x="5450978" y="3023999"/>
             <a:ext cx="2419489" cy="162000"/>
           </a:xfrm>
           <a:prstGeom prst="rect">
@@ -12902,7 +13013,7 @@
         </p:nvSpPr>
         <p:spPr>
           <a:xfrm>
-            <a:off x="7906468" y="2790000"/>
+            <a:off x="7906468" y="3005999"/>
             <a:ext cx="2020491" cy="198000"/>
           </a:xfrm>
           <a:prstGeom prst="rect">
@@ -12945,7 +13056,7 @@
         </p:nvSpPr>
         <p:spPr>
           <a:xfrm>
-            <a:off x="7942468" y="2808000"/>
+            <a:off x="7942468" y="3023999"/>
             <a:ext cx="1966491" cy="162000"/>
           </a:xfrm>
           <a:prstGeom prst="rect">
@@ -12979,7 +13090,7 @@
         </p:nvSpPr>
         <p:spPr>
           <a:xfrm>
-            <a:off x="432000" y="3096000"/>
+            <a:off x="432000" y="3311999"/>
             <a:ext cx="11324952" cy="324000"/>
           </a:xfrm>
           <a:prstGeom prst="rect">
@@ -13022,7 +13133,7 @@
         </p:nvSpPr>
         <p:spPr>
           <a:xfrm>
-            <a:off x="540000" y="3124800"/>
+            <a:off x="540000" y="3340799"/>
             <a:ext cx="11108952" cy="288000"/>
           </a:xfrm>
           <a:prstGeom prst="rect">
@@ -13202,8 +13313,8 @@
         </p:blipFill>
         <p:spPr>
           <a:xfrm>
-            <a:off x="432000" y="756000"/>
-            <a:ext cx="11324952" cy="1512000"/>
+            <a:off x="3793906" y="756000"/>
+            <a:ext cx="4601140" cy="1655999"/>
           </a:xfrm>
           <a:prstGeom prst="rect">
             <a:avLst/>
@@ -13218,7 +13329,7 @@
         </p:nvSpPr>
         <p:spPr>
           <a:xfrm>
-            <a:off x="432000" y="2340000"/>
+            <a:off x="432000" y="2484000"/>
             <a:ext cx="11324952" cy="576000"/>
           </a:xfrm>
           <a:prstGeom prst="rect">
@@ -13263,7 +13374,7 @@
         </p:nvSpPr>
         <p:spPr>
           <a:xfrm>
-            <a:off x="540000" y="2368800"/>
+            <a:off x="540000" y="2512800"/>
             <a:ext cx="2880000" cy="198000"/>
           </a:xfrm>
           <a:prstGeom prst="rect">
@@ -13297,7 +13408,7 @@
         </p:nvSpPr>
         <p:spPr>
           <a:xfrm>
-            <a:off x="540000" y="2574000"/>
+            <a:off x="540000" y="2718000"/>
             <a:ext cx="11108952" cy="324000"/>
           </a:xfrm>
           <a:prstGeom prst="rect">

</xml_diff>

<commit_message>
docs(presentation): reframe deck to honest contribution positioning
- transition-models 기여를 'feature 생성'이 아니라 'baseline 재현 + 공정
  비교 + 상류 clustering context 효과 검증 + RL handoff'로 정정
- Slide 2 신규: 왜 전이확률 + 파트별 기여 분담표 (data/clustering/tm/rl)
- Slide 3: '초기 접근 = baseline 재현 (새 모델 발명 아님)'
- Slide 7/9: Transformer vs MLP10 = 우열 아닌 참고 비교, MLP10은 MDP
  전이함수 형태에 맞아 후보; Q=Σp·[RE24+γV] 흐름 + history 부적합 명시
- Slide 8: arsenal context = 효과 '검증'(생성 아님) 단서 추가
- fig2 출처 표현 수정 (arsenal 58d 본인 기여 → 상류 context 활용)

Co-Authored-By: Claude Opus 4.8 (1M context) <noreply@anthropic.com>
</commit_message>
<xml_diff>
--- a/outputs/SmartPitch_TransitionModels_Presentation.pptx
+++ b/outputs/SmartPitch_TransitionModels_Presentation.pptx
@@ -3206,12 +3206,12 @@
           <a:p>
             <a:pPr algn="ctr"/>
             <a:r>
-              <a:rPr sz="3600" b="1">
+              <a:rPr sz="3200" b="1">
                 <a:solidFill>
                   <a:srgbClr val="FFFFFF"/>
                 </a:solidFill>
               </a:rPr>
-              <a:t>전이확률 모델 비교 실험</a:t>
+              <a:t>투구 결과 전이확률 모델 — 비교·검증</a:t>
             </a:r>
           </a:p>
         </p:txBody>
@@ -3240,12 +3240,12 @@
           <a:p>
             <a:pPr algn="ctr"/>
             <a:r>
-              <a:rPr sz="1600" b="0">
+              <a:rPr sz="1400" b="0">
                 <a:solidFill>
                   <a:srgbClr val="95A5A6"/>
                 </a:solidFill>
               </a:rPr>
-              <a:t>Transition Probability Model Comparison</a:t>
+              <a:t>RL 환경이 쓸 P(outcome | state, action, context) 추정 + 어떤 모델이 MDP 보상에 적합한지 비교</a:t>
             </a:r>
           </a:p>
         </p:txBody>
@@ -3434,7 +3434,7 @@
                   <a:srgbClr val="E67E22"/>
                 </a:solidFill>
               </a:rPr>
-              <a:t>재현 논문</a:t>
+              <a:t>재현 baseline</a:t>
             </a:r>
           </a:p>
         </p:txBody>
@@ -3468,8 +3468,8 @@
                   <a:srgbClr val="FFFFFF"/>
                 </a:solidFill>
               </a:rPr>
-              <a:t>Otremba 2022
-MIT Sloan 2025</a:t>
+              <a:t>Otremba 2022 MLP
+MIT Sloan 2025 Transformer</a:t>
             </a:r>
           </a:p>
         </p:txBody>
@@ -3546,7 +3546,7 @@
                   <a:srgbClr val="E67E22"/>
                 </a:solidFill>
               </a:rPr>
-              <a:t>주요 발견</a:t>
+              <a:t>핵심 기여</a:t>
             </a:r>
           </a:p>
         </p:txBody>
@@ -3580,8 +3580,8 @@
                   <a:srgbClr val="FFFFFF"/>
                 </a:solidFill>
               </a:rPr>
-              <a:t>Arsenal Context 58d
-Collapse 해소 + MDP 호환</a:t>
+              <a:t>baseline 재현·공정 비교
+context 효과 검증·RL handoff</a:t>
             </a:r>
           </a:p>
         </p:txBody>
@@ -3718,7 +3718,7 @@
                   <a:srgbClr val="FFFFFF"/>
                 </a:solidFill>
               </a:rPr>
-              <a:t>결론 &amp; 팀 통합</a:t>
+              <a:t>결론 &amp; 정직한 기여 정리</a:t>
             </a:r>
           </a:p>
         </p:txBody>
@@ -3765,128 +3765,14 @@
         </p:nvSpPr>
         <p:spPr>
           <a:xfrm>
-            <a:off x="432000" y="828000"/>
-            <a:ext cx="6794971" cy="450000"/>
+            <a:off x="432000" y="756000"/>
+            <a:ext cx="6794971" cy="432000"/>
           </a:xfrm>
           <a:prstGeom prst="rect">
             <a:avLst/>
           </a:prstGeom>
           <a:solidFill>
-            <a:srgbClr val="F8F9FA"/>
-          </a:solidFill>
-          <a:ln w="25400">
-            <a:solidFill>
-              <a:srgbClr val="E74C3C"/>
-            </a:solidFill>
-          </a:ln>
-        </p:spPr>
-        <p:style>
-          <a:lnRef idx="1">
-            <a:schemeClr val="accent1"/>
-          </a:lnRef>
-          <a:fillRef idx="3">
-            <a:schemeClr val="accent1"/>
-          </a:fillRef>
-          <a:effectRef idx="2">
-            <a:schemeClr val="accent1"/>
-          </a:effectRef>
-          <a:fontRef idx="minor">
-            <a:schemeClr val="lt1"/>
-          </a:fontRef>
-        </p:style>
-        <p:txBody>
-          <a:bodyPr rtlCol="0" anchor="ctr"/>
-          <a:lstStyle/>
-          <a:p>
-            <a:pPr algn="ctr"/>
-          </a:p>
-        </p:txBody>
-      </p:sp>
-      <p:sp>
-        <p:nvSpPr>
-          <p:cNvPr id="6" name="TextBox 5"/>
-          <p:cNvSpPr txBox="1"/>
-          <p:nvPr/>
-        </p:nvSpPr>
-        <p:spPr>
-          <a:xfrm>
-            <a:off x="540000" y="856800"/>
-            <a:ext cx="6455222" cy="180000"/>
-          </a:xfrm>
-          <a:prstGeom prst="rect">
-            <a:avLst/>
-          </a:prstGeom>
-          <a:noFill/>
-        </p:spPr>
-        <p:txBody>
-          <a:bodyPr wrap="square">
-            <a:spAutoFit/>
-          </a:bodyPr>
-          <a:lstStyle/>
-          <a:p>
-            <a:pPr algn="l"/>
-            <a:r>
-              <a:rPr sz="1300" b="1">
-                <a:solidFill>
-                  <a:srgbClr val="E74C3C"/>
-                </a:solidFill>
-              </a:rPr>
-              <a:t>① Collapse 원인 규명</a:t>
-            </a:r>
-          </a:p>
-        </p:txBody>
-      </p:sp>
-      <p:sp>
-        <p:nvSpPr>
-          <p:cNvPr id="7" name="TextBox 6"/>
-          <p:cNvSpPr txBox="1"/>
-          <p:nvPr/>
-        </p:nvSpPr>
-        <p:spPr>
-          <a:xfrm>
-            <a:off x="540000" y="1036800"/>
-            <a:ext cx="6455222" cy="234000"/>
-          </a:xfrm>
-          <a:prstGeom prst="rect">
-            <a:avLst/>
-          </a:prstGeom>
-          <a:noFill/>
-        </p:spPr>
-        <p:txBody>
-          <a:bodyPr wrap="square">
-            <a:spAutoFit/>
-          </a:bodyPr>
-          <a:lstStyle/>
-          <a:p>
-            <a:pPr algn="l"/>
-            <a:r>
-              <a:rPr sz="1000" b="0">
-                <a:solidFill>
-                  <a:srgbClr val="2C3E50"/>
-                </a:solidFill>
-              </a:rPr>
-              <a:t>77d i.i.d. 모델 collapse = 투수 맥락(pitcher context) 부재
-class balancing · Focal Loss 모두 무효 — feature 구조 문제</a:t>
-            </a:r>
-          </a:p>
-        </p:txBody>
-      </p:sp>
-      <p:sp>
-        <p:nvSpPr>
-          <p:cNvPr id="8" name="Rectangle 7"/>
-          <p:cNvSpPr/>
-          <p:nvPr/>
-        </p:nvSpPr>
-        <p:spPr>
-          <a:xfrm>
-            <a:off x="432000" y="1331999"/>
-            <a:ext cx="6794971" cy="450000"/>
-          </a:xfrm>
-          <a:prstGeom prst="rect">
-            <a:avLst/>
-          </a:prstGeom>
-          <a:solidFill>
-            <a:srgbClr val="F8F9FA"/>
+            <a:srgbClr val="FFF3E0"/>
           </a:solidFill>
           <a:ln w="25400">
             <a:solidFill>
@@ -3918,14 +3804,117 @@
       </p:sp>
       <p:sp>
         <p:nvSpPr>
+          <p:cNvPr id="6" name="TextBox 5"/>
+          <p:cNvSpPr txBox="1"/>
+          <p:nvPr/>
+        </p:nvSpPr>
+        <p:spPr>
+          <a:xfrm>
+            <a:off x="540000" y="792000"/>
+            <a:ext cx="6455222" cy="378000"/>
+          </a:xfrm>
+          <a:prstGeom prst="rect">
+            <a:avLst/>
+          </a:prstGeom>
+          <a:noFill/>
+        </p:spPr>
+        <p:txBody>
+          <a:bodyPr wrap="square">
+            <a:spAutoFit/>
+          </a:bodyPr>
+          <a:lstStyle/>
+          <a:p>
+            <a:pPr algn="l"/>
+            <a:r>
+              <a:rPr sz="1150" b="1">
+                <a:solidFill>
+                  <a:srgbClr val="2C3E50"/>
+                </a:solidFill>
+              </a:rPr>
+              <a:t>"투구를 잘 예측하는 모델" ≠ "RL 보상 계산에 쓰기 좋은 전이모델"
+내 파트 = 후자 관점에서 어떤 입력/모델이 적합한지 객관적으로 가려낸 것</a:t>
+            </a:r>
+          </a:p>
+        </p:txBody>
+      </p:sp>
+      <p:sp>
+        <p:nvSpPr>
+          <p:cNvPr id="7" name="TextBox 6"/>
+          <p:cNvSpPr txBox="1"/>
+          <p:nvPr/>
+        </p:nvSpPr>
+        <p:spPr>
+          <a:xfrm>
+            <a:off x="432000" y="1296000"/>
+            <a:ext cx="6794971" cy="180000"/>
+          </a:xfrm>
+          <a:prstGeom prst="rect">
+            <a:avLst/>
+          </a:prstGeom>
+          <a:noFill/>
+        </p:spPr>
+        <p:txBody>
+          <a:bodyPr wrap="square">
+            <a:spAutoFit/>
+          </a:bodyPr>
+          <a:lstStyle/>
+          <a:p>
+            <a:pPr algn="l"/>
+            <a:r>
+              <a:rPr sz="1300" b="1">
+                <a:solidFill>
+                  <a:srgbClr val="2980B9"/>
+                </a:solidFill>
+              </a:rPr>
+              <a:t>transition-models 기여 (과장 없이)</a:t>
+            </a:r>
+          </a:p>
+        </p:txBody>
+      </p:sp>
+      <p:sp>
+        <p:nvSpPr>
+          <p:cNvPr id="8" name="TextBox 7"/>
+          <p:cNvSpPr txBox="1"/>
+          <p:nvPr/>
+        </p:nvSpPr>
+        <p:spPr>
+          <a:xfrm>
+            <a:off x="468000" y="1512000"/>
+            <a:ext cx="6794971" cy="198000"/>
+          </a:xfrm>
+          <a:prstGeom prst="rect">
+            <a:avLst/>
+          </a:prstGeom>
+          <a:noFill/>
+        </p:spPr>
+        <p:txBody>
+          <a:bodyPr wrap="square">
+            <a:spAutoFit/>
+          </a:bodyPr>
+          <a:lstStyle/>
+          <a:p>
+            <a:pPr algn="l"/>
+            <a:r>
+              <a:rPr sz="1080" b="0">
+                <a:solidFill>
+                  <a:srgbClr val="2C3E50"/>
+                </a:solidFill>
+              </a:rPr>
+              <a:t>① 논문 baseline 재현 (Otremba MLP · MIT Sloan Transformer)</a:t>
+            </a:r>
+          </a:p>
+        </p:txBody>
+      </p:sp>
+      <p:sp>
+        <p:nvSpPr>
           <p:cNvPr id="9" name="TextBox 8"/>
           <p:cNvSpPr txBox="1"/>
           <p:nvPr/>
         </p:nvSpPr>
         <p:spPr>
           <a:xfrm>
-            <a:off x="540000" y="1360799"/>
-            <a:ext cx="6455222" cy="180000"/>
+            <a:off x="468000" y="1735200"/>
+            <a:ext cx="6794971" cy="198000"/>
           </a:xfrm>
           <a:prstGeom prst="rect">
             <a:avLst/>
@@ -3940,12 +3929,12 @@
           <a:p>
             <a:pPr algn="l"/>
             <a:r>
-              <a:rPr sz="1300" b="1">
-                <a:solidFill>
-                  <a:srgbClr val="E67E22"/>
-                </a:solidFill>
-              </a:rPr>
-              <a:t>② Context = Architecture-Agnostic</a:t>
+              <a:rPr sz="1080" b="0">
+                <a:solidFill>
+                  <a:srgbClr val="2C3E50"/>
+                </a:solidFill>
+              </a:rPr>
+              <a:t>② 공정 비교 기준 수립 (Top-1+Macro-F1+CE, 같은 입력조건·test set 그룹)</a:t>
             </a:r>
           </a:p>
         </p:txBody>
@@ -3958,8 +3947,8 @@
         </p:nvSpPr>
         <p:spPr>
           <a:xfrm>
-            <a:off x="540000" y="1540799"/>
-            <a:ext cx="6455222" cy="234000"/>
+            <a:off x="468000" y="1958400"/>
+            <a:ext cx="6794971" cy="198000"/>
           </a:xfrm>
           <a:prstGeom prst="rect">
             <a:avLst/>
@@ -3974,59 +3963,47 @@
           <a:p>
             <a:pPr algn="l"/>
             <a:r>
-              <a:rPr sz="1000" b="0">
+              <a:rPr sz="1080" b="0">
                 <a:solidFill>
                   <a:srgbClr val="2C3E50"/>
                 </a:solidFill>
               </a:rPr>
-              <a:t>arsenal 58d 추가 → LR +21pp, LGB +54pp, MLP +27pp
-Top-1은 sequence baseline과 유사, MDP 호환성이 강점</a:t>
-            </a:r>
-          </a:p>
-        </p:txBody>
-      </p:sp>
-      <p:sp>
-        <p:nvSpPr>
-          <p:cNvPr id="11" name="Rectangle 10"/>
-          <p:cNvSpPr/>
-          <p:nvPr/>
-        </p:nvSpPr>
-        <p:spPr>
-          <a:xfrm>
-            <a:off x="432000" y="1835998"/>
-            <a:ext cx="6794971" cy="450000"/>
-          </a:xfrm>
-          <a:prstGeom prst="rect">
-            <a:avLst/>
-          </a:prstGeom>
-          <a:solidFill>
-            <a:srgbClr val="F8F9FA"/>
-          </a:solidFill>
-          <a:ln w="25400">
-            <a:solidFill>
-              <a:srgbClr val="2980B9"/>
-            </a:solidFill>
-          </a:ln>
-        </p:spPr>
-        <p:style>
-          <a:lnRef idx="1">
-            <a:schemeClr val="accent1"/>
-          </a:lnRef>
-          <a:fillRef idx="3">
-            <a:schemeClr val="accent1"/>
-          </a:fillRef>
-          <a:effectRef idx="2">
-            <a:schemeClr val="accent1"/>
-          </a:effectRef>
-          <a:fontRef idx="minor">
-            <a:schemeClr val="lt1"/>
-          </a:fontRef>
-        </p:style>
-        <p:txBody>
-          <a:bodyPr rtlCol="0" anchor="ctr"/>
-          <a:lstStyle/>
-          <a:p>
-            <a:pPr algn="ctr"/>
+              <a:t>③ collapse 분석 (77d 41.1% → Macro-F1 5.8% 폭로)</a:t>
+            </a:r>
+          </a:p>
+        </p:txBody>
+      </p:sp>
+      <p:sp>
+        <p:nvSpPr>
+          <p:cNvPr id="11" name="TextBox 10"/>
+          <p:cNvSpPr txBox="1"/>
+          <p:nvPr/>
+        </p:nvSpPr>
+        <p:spPr>
+          <a:xfrm>
+            <a:off x="468000" y="2181600"/>
+            <a:ext cx="6794971" cy="198000"/>
+          </a:xfrm>
+          <a:prstGeom prst="rect">
+            <a:avLst/>
+          </a:prstGeom>
+          <a:noFill/>
+        </p:spPr>
+        <p:txBody>
+          <a:bodyPr wrap="square">
+            <a:spAutoFit/>
+          </a:bodyPr>
+          <a:lstStyle/>
+          <a:p>
+            <a:pPr algn="l"/>
+            <a:r>
+              <a:rPr sz="1080" b="0">
+                <a:solidFill>
+                  <a:srgbClr val="2C3E50"/>
+                </a:solidFill>
+              </a:rPr>
+              <a:t>④ 상류 context feature 효과 검증 (+26.5pp, 생성❌ 검증✅)</a:t>
+            </a:r>
           </a:p>
         </p:txBody>
       </p:sp>
@@ -4038,8 +4015,8 @@
         </p:nvSpPr>
         <p:spPr>
           <a:xfrm>
-            <a:off x="540000" y="1864798"/>
-            <a:ext cx="6455222" cy="180000"/>
+            <a:off x="468000" y="2404800"/>
+            <a:ext cx="6794971" cy="198000"/>
           </a:xfrm>
           <a:prstGeom prst="rect">
             <a:avLst/>
@@ -4054,54 +4031,19 @@
           <a:p>
             <a:pPr algn="l"/>
             <a:r>
-              <a:rPr sz="1300" b="1">
-                <a:solidFill>
-                  <a:srgbClr val="2980B9"/>
-                </a:solidFill>
-              </a:rPr>
-              <a:t>③ Sequence는 Context를 내재 학습</a:t>
-            </a:r>
-          </a:p>
-        </p:txBody>
-      </p:sp>
-      <p:sp>
-        <p:nvSpPr>
-          <p:cNvPr id="13" name="TextBox 12"/>
-          <p:cNvSpPr txBox="1"/>
-          <p:nvPr/>
-        </p:nvSpPr>
-        <p:spPr>
-          <a:xfrm>
-            <a:off x="540000" y="2044798"/>
-            <a:ext cx="6455222" cy="234000"/>
-          </a:xfrm>
-          <a:prstGeom prst="rect">
-            <a:avLst/>
-          </a:prstGeom>
-          <a:noFill/>
-        </p:spPr>
-        <p:txBody>
-          <a:bodyPr wrap="square">
-            <a:spAutoFit/>
-          </a:bodyPr>
-          <a:lstStyle/>
-          <a:p>
-            <a:pPr algn="l"/>
-            <a:r>
-              <a:rPr sz="1000" b="0">
+              <a:rPr sz="1080" b="0">
                 <a:solidFill>
                   <a:srgbClr val="2C3E50"/>
                 </a:solidFill>
               </a:rPr>
-              <a:t>RNN/Transformer에 static context 추가 → 효과 없음
-400-pitch history가 arsenal context를 이미 포함</a:t>
-            </a:r>
-          </a:p>
-        </p:txBody>
-      </p:sp>
-      <p:sp>
-        <p:nvSpPr>
-          <p:cNvPr id="14" name="Rectangle 13"/>
+              <a:t>⑤ RL handoff (MDP 호환 MLP10 + inference wrapper + 문서)</a:t>
+            </a:r>
+          </a:p>
+        </p:txBody>
+      </p:sp>
+      <p:sp>
+        <p:nvSpPr>
+          <p:cNvPr id="13" name="Rectangle 12"/>
           <p:cNvSpPr/>
           <p:nvPr/>
         </p:nvSpPr>
@@ -4144,7 +4086,7 @@
       </p:sp>
       <p:sp>
         <p:nvSpPr>
-          <p:cNvPr id="15" name="TextBox 14"/>
+          <p:cNvPr id="14" name="TextBox 13"/>
           <p:cNvSpPr txBox="1"/>
           <p:nvPr/>
         </p:nvSpPr>
@@ -4178,7 +4120,7 @@
       </p:sp>
       <p:sp>
         <p:nvSpPr>
-          <p:cNvPr id="16" name="TextBox 15"/>
+          <p:cNvPr id="15" name="TextBox 14"/>
           <p:cNvSpPr txBox="1"/>
           <p:nvPr/>
         </p:nvSpPr>
@@ -4219,13 +4161,47 @@
       </p:sp>
       <p:sp>
         <p:nvSpPr>
+          <p:cNvPr id="16" name="TextBox 15"/>
+          <p:cNvSpPr txBox="1"/>
+          <p:nvPr/>
+        </p:nvSpPr>
+        <p:spPr>
+          <a:xfrm>
+            <a:off x="432000" y="2736000"/>
+            <a:ext cx="6703923" cy="180000"/>
+          </a:xfrm>
+          <a:prstGeom prst="rect">
+            <a:avLst/>
+          </a:prstGeom>
+          <a:noFill/>
+        </p:spPr>
+        <p:txBody>
+          <a:bodyPr wrap="square">
+            <a:spAutoFit/>
+          </a:bodyPr>
+          <a:lstStyle/>
+          <a:p>
+            <a:pPr algn="l"/>
+            <a:r>
+              <a:rPr sz="1300" b="1">
+                <a:solidFill>
+                  <a:srgbClr val="2C3E50"/>
+                </a:solidFill>
+              </a:rPr>
+              <a:t>Future Work</a:t>
+            </a:r>
+          </a:p>
+        </p:txBody>
+      </p:sp>
+      <p:sp>
+        <p:nvSpPr>
           <p:cNvPr id="17" name="TextBox 16"/>
           <p:cNvSpPr txBox="1"/>
           <p:nvPr/>
         </p:nvSpPr>
         <p:spPr>
           <a:xfrm>
-            <a:off x="432000" y="2447997"/>
+            <a:off x="504000" y="2952000"/>
             <a:ext cx="6703923" cy="180000"/>
           </a:xfrm>
           <a:prstGeom prst="rect">
@@ -4241,12 +4217,12 @@
           <a:p>
             <a:pPr algn="l"/>
             <a:r>
-              <a:rPr sz="1300" b="1">
+              <a:rPr sz="1050" b="0">
                 <a:solidFill>
                   <a:srgbClr val="2C3E50"/>
                 </a:solidFill>
               </a:rPr>
-              <a:t>Future Work</a:t>
+              <a:t>• MLP10H RL 비교 강화 → BIP 보상 안정화</a:t>
             </a:r>
           </a:p>
         </p:txBody>
@@ -4259,7 +4235,7 @@
         </p:nvSpPr>
         <p:spPr>
           <a:xfrm>
-            <a:off x="504000" y="2663997"/>
+            <a:off x="504000" y="3132000"/>
             <a:ext cx="6703923" cy="180000"/>
           </a:xfrm>
           <a:prstGeom prst="rect">
@@ -4280,7 +4256,7 @@
                   <a:srgbClr val="2C3E50"/>
                 </a:solidFill>
               </a:rPr>
-              <a:t>• MLP10H RL 비교 강화 → BIP 보상 안정화</a:t>
+              <a:t>• 타자 arsenal feature → Single~HR 0% 해결</a:t>
             </a:r>
           </a:p>
         </p:txBody>
@@ -4293,7 +4269,7 @@
         </p:nvSpPr>
         <p:spPr>
           <a:xfrm>
-            <a:off x="504000" y="2843997"/>
+            <a:off x="504000" y="3312000"/>
             <a:ext cx="6703923" cy="180000"/>
           </a:xfrm>
           <a:prstGeom prst="rect">
@@ -4314,7 +4290,7 @@
                   <a:srgbClr val="2C3E50"/>
                 </a:solidFill>
               </a:rPr>
-              <a:t>• 타자 arsenal feature → Single~HR 0% 해결</a:t>
+              <a:t>• Small Transformer (2-layer) MDP 호환 탐색</a:t>
             </a:r>
           </a:p>
         </p:txBody>
@@ -4327,41 +4303,7 @@
         </p:nvSpPr>
         <p:spPr>
           <a:xfrm>
-            <a:off x="504000" y="3023997"/>
-            <a:ext cx="6703923" cy="180000"/>
-          </a:xfrm>
-          <a:prstGeom prst="rect">
-            <a:avLst/>
-          </a:prstGeom>
-          <a:noFill/>
-        </p:spPr>
-        <p:txBody>
-          <a:bodyPr wrap="square">
-            <a:spAutoFit/>
-          </a:bodyPr>
-          <a:lstStyle/>
-          <a:p>
-            <a:pPr algn="l"/>
-            <a:r>
-              <a:rPr sz="1050" b="0">
-                <a:solidFill>
-                  <a:srgbClr val="2C3E50"/>
-                </a:solidFill>
-              </a:rPr>
-              <a:t>• Small Transformer (2-layer) MDP 호환 탐색</a:t>
-            </a:r>
-          </a:p>
-        </p:txBody>
-      </p:sp>
-      <p:sp>
-        <p:nvSpPr>
-          <p:cNvPr id="21" name="TextBox 20"/>
-          <p:cNvSpPr txBox="1"/>
-          <p:nvPr/>
-        </p:nvSpPr>
-        <p:spPr>
-          <a:xfrm>
-            <a:off x="504000" y="3203997"/>
+            <a:off x="504000" y="3492000"/>
             <a:ext cx="6703923" cy="180000"/>
           </a:xfrm>
           <a:prstGeom prst="rect">
@@ -4485,7 +4427,7 @@
                   <a:srgbClr val="FFFFFF"/>
                 </a:solidFill>
               </a:rPr>
-              <a:t>문제 정의 &amp; 연구 목표</a:t>
+              <a:t>왜 전이확률인가 + 파트별 기여 분담</a:t>
             </a:r>
           </a:p>
         </p:txBody>
@@ -4526,54 +4468,20 @@
       </p:sp>
       <p:sp>
         <p:nvSpPr>
-          <p:cNvPr id="5" name="TextBox 4"/>
-          <p:cNvSpPr txBox="1"/>
+          <p:cNvPr id="5" name="Rectangle 4"/>
+          <p:cNvSpPr/>
           <p:nvPr/>
         </p:nvSpPr>
         <p:spPr>
           <a:xfrm>
             <a:off x="432000" y="756000"/>
-            <a:ext cx="11324952" cy="360000"/>
-          </a:xfrm>
-          <a:prstGeom prst="rect">
-            <a:avLst/>
-          </a:prstGeom>
-          <a:noFill/>
-        </p:spPr>
-        <p:txBody>
-          <a:bodyPr wrap="square">
-            <a:spAutoFit/>
-          </a:bodyPr>
-          <a:lstStyle/>
-          <a:p>
-            <a:pPr algn="l"/>
-            <a:r>
-              <a:rPr sz="1800" b="1">
-                <a:solidFill>
-                  <a:srgbClr val="2C3E50"/>
-                </a:solidFill>
-              </a:rPr>
-              <a:t>MDP 전이확률  P(outcome | pitch, context) 추정</a:t>
-            </a:r>
-          </a:p>
-        </p:txBody>
-      </p:sp>
-      <p:sp>
-        <p:nvSpPr>
-          <p:cNvPr id="6" name="Rectangle 5"/>
-          <p:cNvSpPr/>
-          <p:nvPr/>
-        </p:nvSpPr>
-        <p:spPr>
-          <a:xfrm>
-            <a:off x="432000" y="1152000"/>
-            <a:ext cx="5482476" cy="1007999"/>
+            <a:ext cx="11324952" cy="306000"/>
           </a:xfrm>
           <a:prstGeom prst="rect">
             <a:avLst/>
           </a:prstGeom>
           <a:solidFill>
-            <a:srgbClr val="F0F4F8"/>
+            <a:srgbClr val="EBF5FB"/>
           </a:solidFill>
           <a:ln>
             <a:noFill/>
@@ -4603,63 +4511,57 @@
       </p:sp>
       <p:sp>
         <p:nvSpPr>
-          <p:cNvPr id="7" name="TextBox 6"/>
-          <p:cNvSpPr txBox="1"/>
-          <p:nvPr/>
-        </p:nvSpPr>
-        <p:spPr>
-          <a:xfrm>
-            <a:off x="540000" y="1188000"/>
-            <a:ext cx="5302476" cy="936000"/>
-          </a:xfrm>
-          <a:prstGeom prst="rect">
-            <a:avLst/>
-          </a:prstGeom>
-          <a:noFill/>
-        </p:spPr>
-        <p:txBody>
-          <a:bodyPr wrap="square">
-            <a:spAutoFit/>
-          </a:bodyPr>
-          <a:lstStyle/>
-          <a:p>
-            <a:pPr algn="l"/>
-            <a:r>
-              <a:rPr sz="1100" b="0">
-                <a:solidFill>
-                  <a:srgbClr val="2C3E50"/>
-                </a:solidFill>
-              </a:rPr>
-              <a:t>state s  = 볼카운트 · 주자상황 · 이닝 ...
-action a = 투구 종류 · 위치
-outcome  = Ball / Strike / Foul / InPlay  (4-class)
-         = Ball / Strike / Single / Double / Triple
-           / HR / FieldOut / Strikeout / Walk / HBP  (10-class)</a:t>
-            </a:r>
-          </a:p>
-        </p:txBody>
-      </p:sp>
-      <p:sp>
-        <p:nvSpPr>
-          <p:cNvPr id="8" name="Rectangle 7"/>
+          <p:cNvPr id="6" name="TextBox 5"/>
+          <p:cNvSpPr txBox="1"/>
+          <p:nvPr/>
+        </p:nvSpPr>
+        <p:spPr>
+          <a:xfrm>
+            <a:off x="540000" y="792000"/>
+            <a:ext cx="11108952" cy="234000"/>
+          </a:xfrm>
+          <a:prstGeom prst="rect">
+            <a:avLst/>
+          </a:prstGeom>
+          <a:noFill/>
+        </p:spPr>
+        <p:txBody>
+          <a:bodyPr wrap="square">
+            <a:spAutoFit/>
+          </a:bodyPr>
+          <a:lstStyle/>
+          <a:p>
+            <a:pPr algn="ctr"/>
+            <a:r>
+              <a:rPr sz="1400" b="1">
+                <a:solidFill>
+                  <a:srgbClr val="2980B9"/>
+                </a:solidFill>
+              </a:rPr>
+              <a:t>data  →  clustering  →  [ transition-models ]  →  rl-agent</a:t>
+            </a:r>
+          </a:p>
+        </p:txBody>
+      </p:sp>
+      <p:sp>
+        <p:nvSpPr>
+          <p:cNvPr id="7" name="Rectangle 6"/>
           <p:cNvSpPr/>
           <p:nvPr/>
         </p:nvSpPr>
         <p:spPr>
           <a:xfrm>
-            <a:off x="6202476" y="1152000"/>
-            <a:ext cx="5554476" cy="396000"/>
+            <a:off x="432000" y="1116000"/>
+            <a:ext cx="11324952" cy="342000"/>
           </a:xfrm>
           <a:prstGeom prst="rect">
             <a:avLst/>
           </a:prstGeom>
           <a:solidFill>
-            <a:srgbClr val="F8F9FA"/>
+            <a:srgbClr val="FFF3E0"/>
           </a:solidFill>
-          <a:ln w="25400">
-            <a:solidFill>
-              <a:srgbClr val="E74C3C"/>
-            </a:solidFill>
+          <a:ln>
+            <a:noFill/>
           </a:ln>
         </p:spPr>
         <p:style>
@@ -4686,14 +4588,48 @@
       </p:sp>
       <p:sp>
         <p:nvSpPr>
+          <p:cNvPr id="8" name="TextBox 7"/>
+          <p:cNvSpPr txBox="1"/>
+          <p:nvPr/>
+        </p:nvSpPr>
+        <p:spPr>
+          <a:xfrm>
+            <a:off x="540000" y="1159200"/>
+            <a:ext cx="11108952" cy="251999"/>
+          </a:xfrm>
+          <a:prstGeom prst="rect">
+            <a:avLst/>
+          </a:prstGeom>
+          <a:noFill/>
+        </p:spPr>
+        <p:txBody>
+          <a:bodyPr wrap="square">
+            <a:spAutoFit/>
+          </a:bodyPr>
+          <a:lstStyle/>
+          <a:p>
+            <a:pPr algn="ctr"/>
+            <a:r>
+              <a:rPr sz="1150" b="0">
+                <a:solidFill>
+                  <a:srgbClr val="2C3E50"/>
+                </a:solidFill>
+              </a:rPr>
+              <a:t>투구 a  →  P(outcome | s, a) [transition-models]  →  다음 상태 + RE24 보상  →  장기 정책   (정확/보정이 좋을수록 보상·정책이 정확)</a:t>
+            </a:r>
+          </a:p>
+        </p:txBody>
+      </p:sp>
+      <p:sp>
+        <p:nvSpPr>
           <p:cNvPr id="9" name="TextBox 8"/>
           <p:cNvSpPr txBox="1"/>
           <p:nvPr/>
         </p:nvSpPr>
         <p:spPr>
           <a:xfrm>
-            <a:off x="6310476" y="1170000"/>
-            <a:ext cx="5338476" cy="180000"/>
+            <a:off x="432000" y="1583999"/>
+            <a:ext cx="11324952" cy="198000"/>
           </a:xfrm>
           <a:prstGeom prst="rect">
             <a:avLst/>
@@ -4708,60 +4644,26 @@
           <a:p>
             <a:pPr algn="l"/>
             <a:r>
-              <a:rPr sz="1200" b="1">
-                <a:solidFill>
-                  <a:srgbClr val="E74C3C"/>
-                </a:solidFill>
-              </a:rPr>
-              <a:t>Otremba 2022 (SmartPitch)</a:t>
-            </a:r>
-          </a:p>
-        </p:txBody>
-      </p:sp>
-      <p:sp>
-        <p:nvSpPr>
-          <p:cNvPr id="10" name="TextBox 9"/>
-          <p:cNvSpPr txBox="1"/>
-          <p:nvPr/>
-        </p:nvSpPr>
-        <p:spPr>
-          <a:xfrm>
-            <a:off x="6310476" y="1350000"/>
-            <a:ext cx="5338476" cy="198000"/>
-          </a:xfrm>
-          <a:prstGeom prst="rect">
-            <a:avLst/>
-          </a:prstGeom>
-          <a:noFill/>
-        </p:spPr>
-        <p:txBody>
-          <a:bodyPr wrap="square">
-            <a:spAutoFit/>
-          </a:bodyPr>
-          <a:lstStyle/>
-          <a:p>
-            <a:pPr algn="l"/>
-            <a:r>
-              <a:rPr sz="1000" b="0">
+              <a:rPr sz="1400" b="1">
                 <a:solidFill>
                   <a:srgbClr val="2C3E50"/>
                 </a:solidFill>
               </a:rPr>
-              <a:t>4-class만 예측, 투수 맥락 feature 없음</a:t>
-            </a:r>
-          </a:p>
-        </p:txBody>
-      </p:sp>
-      <p:sp>
-        <p:nvSpPr>
-          <p:cNvPr id="11" name="Rectangle 10"/>
+              <a:t>파트별 기여 분담 (혼동 방지 — 정직하게)</a:t>
+            </a:r>
+          </a:p>
+        </p:txBody>
+      </p:sp>
+      <p:sp>
+        <p:nvSpPr>
+          <p:cNvPr id="10" name="Rectangle 9"/>
           <p:cNvSpPr/>
           <p:nvPr/>
         </p:nvSpPr>
         <p:spPr>
           <a:xfrm>
-            <a:off x="6202476" y="1620000"/>
-            <a:ext cx="5554476" cy="396000"/>
+            <a:off x="432000" y="1835998"/>
+            <a:ext cx="8153965" cy="259200"/>
           </a:xfrm>
           <a:prstGeom prst="rect">
             <a:avLst/>
@@ -4769,10 +4671,8 @@
           <a:solidFill>
             <a:srgbClr val="F8F9FA"/>
           </a:solidFill>
-          <a:ln w="25400">
-            <a:solidFill>
-              <a:srgbClr val="E67E22"/>
-            </a:solidFill>
+          <a:ln>
+            <a:noFill/>
           </a:ln>
         </p:spPr>
         <p:style>
@@ -4799,14 +4699,14 @@
       </p:sp>
       <p:sp>
         <p:nvSpPr>
-          <p:cNvPr id="12" name="TextBox 11"/>
-          <p:cNvSpPr txBox="1"/>
-          <p:nvPr/>
-        </p:nvSpPr>
-        <p:spPr>
-          <a:xfrm>
-            <a:off x="6310476" y="1638000"/>
-            <a:ext cx="5338476" cy="180000"/>
+          <p:cNvPr id="11" name="TextBox 10"/>
+          <p:cNvSpPr txBox="1"/>
+          <p:nvPr/>
+        </p:nvSpPr>
+        <p:spPr>
+          <a:xfrm>
+            <a:off x="504000" y="1879198"/>
+            <a:ext cx="8009965" cy="223200"/>
           </a:xfrm>
           <a:prstGeom prst="rect">
             <a:avLst/>
@@ -4821,105 +4721,35 @@
           <a:p>
             <a:pPr algn="l"/>
             <a:r>
-              <a:rPr sz="1200" b="1">
-                <a:solidFill>
-                  <a:srgbClr val="E67E22"/>
-                </a:solidFill>
-              </a:rPr>
-              <a:t>MIT Sloan 2025 (Transformer)</a:t>
-            </a:r>
-          </a:p>
-        </p:txBody>
-      </p:sp>
-      <p:sp>
-        <p:nvSpPr>
-          <p:cNvPr id="13" name="TextBox 12"/>
-          <p:cNvSpPr txBox="1"/>
-          <p:nvPr/>
-        </p:nvSpPr>
-        <p:spPr>
-          <a:xfrm>
-            <a:off x="6310476" y="1818000"/>
-            <a:ext cx="5338476" cy="198000"/>
-          </a:xfrm>
-          <a:prstGeom prst="rect">
-            <a:avLst/>
-          </a:prstGeom>
-          <a:noFill/>
-        </p:spPr>
-        <p:txBody>
-          <a:bodyPr wrap="square">
-            <a:spAutoFit/>
-          </a:bodyPr>
-          <a:lstStyle/>
-          <a:p>
-            <a:pPr algn="l"/>
-            <a:r>
-              <a:rPr sz="1000" b="0">
+              <a:rPr sz="1050" b="0">
                 <a:solidFill>
                   <a:srgbClr val="2C3E50"/>
                 </a:solidFill>
               </a:rPr>
-              <a:t>10-class 가능, MDP 비호환 (400-pitch history 필요)</a:t>
-            </a:r>
-          </a:p>
-        </p:txBody>
-      </p:sp>
-      <p:sp>
-        <p:nvSpPr>
-          <p:cNvPr id="14" name="TextBox 13"/>
-          <p:cNvSpPr txBox="1"/>
-          <p:nvPr/>
-        </p:nvSpPr>
-        <p:spPr>
-          <a:xfrm>
-            <a:off x="432000" y="2160000"/>
-            <a:ext cx="4320000" cy="216000"/>
-          </a:xfrm>
-          <a:prstGeom prst="rect">
-            <a:avLst/>
-          </a:prstGeom>
-          <a:noFill/>
-        </p:spPr>
-        <p:txBody>
-          <a:bodyPr wrap="square">
-            <a:spAutoFit/>
-          </a:bodyPr>
-          <a:lstStyle/>
-          <a:p>
-            <a:pPr algn="l"/>
-            <a:r>
-              <a:rPr sz="1400" b="1">
-                <a:solidFill>
-                  <a:srgbClr val="2980B9"/>
-                </a:solidFill>
-              </a:rPr>
-              <a:t>연구 목표</a:t>
-            </a:r>
-          </a:p>
-        </p:txBody>
-      </p:sp>
-      <p:sp>
-        <p:nvSpPr>
-          <p:cNvPr id="15" name="Rectangle 14"/>
+              <a:t>handoff_v1.parquet 생성 · 원천 데이터</a:t>
+            </a:r>
+          </a:p>
+        </p:txBody>
+      </p:sp>
+      <p:sp>
+        <p:nvSpPr>
+          <p:cNvPr id="12" name="Rectangle 11"/>
           <p:cNvSpPr/>
           <p:nvPr/>
         </p:nvSpPr>
         <p:spPr>
           <a:xfrm>
-            <a:off x="432000" y="2411999"/>
-            <a:ext cx="1404000" cy="324000"/>
+            <a:off x="8621965" y="1835998"/>
+            <a:ext cx="3134986" cy="259200"/>
           </a:xfrm>
           <a:prstGeom prst="rect">
             <a:avLst/>
           </a:prstGeom>
           <a:solidFill>
-            <a:srgbClr val="EBF5FB"/>
+            <a:srgbClr val="F8F9FA"/>
           </a:solidFill>
-          <a:ln w="19050">
-            <a:solidFill>
-              <a:srgbClr val="2980B9"/>
-            </a:solidFill>
+          <a:ln>
+            <a:noFill/>
           </a:ln>
         </p:spPr>
         <p:style>
@@ -4946,14 +4776,14 @@
       </p:sp>
       <p:sp>
         <p:nvSpPr>
-          <p:cNvPr id="16" name="TextBox 15"/>
-          <p:cNvSpPr txBox="1"/>
-          <p:nvPr/>
-        </p:nvSpPr>
-        <p:spPr>
-          <a:xfrm>
-            <a:off x="504000" y="2419200"/>
-            <a:ext cx="1260000" cy="151200"/>
+          <p:cNvPr id="13" name="TextBox 12"/>
+          <p:cNvSpPr txBox="1"/>
+          <p:nvPr/>
+        </p:nvSpPr>
+        <p:spPr>
+          <a:xfrm>
+            <a:off x="8675965" y="1879198"/>
+            <a:ext cx="3026986" cy="223200"/>
           </a:xfrm>
           <a:prstGeom prst="rect">
             <a:avLst/>
@@ -4968,71 +4798,35 @@
           <a:p>
             <a:pPr algn="l"/>
             <a:r>
-              <a:rPr sz="1200" b="1">
-                <a:solidFill>
-                  <a:srgbClr val="2980B9"/>
-                </a:solidFill>
-              </a:rPr>
-              <a:t>① 비교 조건 분리</a:t>
-            </a:r>
-          </a:p>
-        </p:txBody>
-      </p:sp>
-      <p:sp>
-        <p:nvSpPr>
-          <p:cNvPr id="17" name="TextBox 16"/>
-          <p:cNvSpPr txBox="1"/>
-          <p:nvPr/>
-        </p:nvSpPr>
-        <p:spPr>
-          <a:xfrm>
-            <a:off x="504000" y="2573999"/>
-            <a:ext cx="1260000" cy="162000"/>
-          </a:xfrm>
-          <a:prstGeom prst="rect">
-            <a:avLst/>
-          </a:prstGeom>
-          <a:noFill/>
-        </p:spPr>
-        <p:txBody>
-          <a:bodyPr wrap="square">
-            <a:spAutoFit/>
-          </a:bodyPr>
-          <a:lstStyle/>
-          <a:p>
-            <a:pPr algn="l"/>
-            <a:r>
-              <a:rPr sz="950" b="0">
-                <a:solidFill>
-                  <a:srgbClr val="2C3E50"/>
-                </a:solidFill>
-              </a:rPr>
-              <a:t>같은 N·지표끼리만 직접 비교</a:t>
-            </a:r>
-          </a:p>
-        </p:txBody>
-      </p:sp>
-      <p:sp>
-        <p:nvSpPr>
-          <p:cNvPr id="18" name="Rectangle 17"/>
+              <a:rPr sz="1050" b="1">
+                <a:solidFill>
+                  <a:srgbClr val="95A5A6"/>
+                </a:solidFill>
+              </a:rPr>
+              <a:t>data 팀</a:t>
+            </a:r>
+          </a:p>
+        </p:txBody>
+      </p:sp>
+      <p:sp>
+        <p:nvSpPr>
+          <p:cNvPr id="14" name="Rectangle 13"/>
           <p:cNvSpPr/>
           <p:nvPr/>
         </p:nvSpPr>
         <p:spPr>
           <a:xfrm>
-            <a:off x="1944000" y="2411999"/>
-            <a:ext cx="1404000" cy="324000"/>
+            <a:off x="432000" y="2116798"/>
+            <a:ext cx="8153965" cy="259200"/>
           </a:xfrm>
           <a:prstGeom prst="rect">
             <a:avLst/>
           </a:prstGeom>
           <a:solidFill>
-            <a:srgbClr val="EBF5FB"/>
+            <a:srgbClr val="F8F9FA"/>
           </a:solidFill>
-          <a:ln w="19050">
-            <a:solidFill>
-              <a:srgbClr val="2980B9"/>
-            </a:solidFill>
+          <a:ln>
+            <a:noFill/>
           </a:ln>
         </p:spPr>
         <p:style>
@@ -5059,14 +4853,14 @@
       </p:sp>
       <p:sp>
         <p:nvSpPr>
-          <p:cNvPr id="19" name="TextBox 18"/>
-          <p:cNvSpPr txBox="1"/>
-          <p:nvPr/>
-        </p:nvSpPr>
-        <p:spPr>
-          <a:xfrm>
-            <a:off x="2016000" y="2419200"/>
-            <a:ext cx="1260000" cy="151200"/>
+          <p:cNvPr id="15" name="TextBox 14"/>
+          <p:cNvSpPr txBox="1"/>
+          <p:nvPr/>
+        </p:nvSpPr>
+        <p:spPr>
+          <a:xfrm>
+            <a:off x="504000" y="2159998"/>
+            <a:ext cx="8009965" cy="223200"/>
           </a:xfrm>
           <a:prstGeom prst="rect">
             <a:avLst/>
@@ -5081,71 +4875,35 @@
           <a:p>
             <a:pPr algn="l"/>
             <a:r>
-              <a:rPr sz="1200" b="1">
-                <a:solidFill>
-                  <a:srgbClr val="2980B9"/>
-                </a:solidFill>
-              </a:rPr>
-              <a:t>② MDP + 10-class</a:t>
-            </a:r>
-          </a:p>
-        </p:txBody>
-      </p:sp>
-      <p:sp>
-        <p:nvSpPr>
-          <p:cNvPr id="20" name="TextBox 19"/>
-          <p:cNvSpPr txBox="1"/>
-          <p:nvPr/>
-        </p:nvSpPr>
-        <p:spPr>
-          <a:xfrm>
-            <a:off x="2016000" y="2573999"/>
-            <a:ext cx="1260000" cy="162000"/>
-          </a:xfrm>
-          <a:prstGeom prst="rect">
-            <a:avLst/>
-          </a:prstGeom>
-          <a:noFill/>
-        </p:spPr>
-        <p:txBody>
-          <a:bodyPr wrap="square">
-            <a:spAutoFit/>
-          </a:bodyPr>
-          <a:lstStyle/>
-          <a:p>
-            <a:pPr algn="l"/>
-            <a:r>
-              <a:rPr sz="950" b="0">
+              <a:rPr sz="1050" b="0">
                 <a:solidFill>
                   <a:srgbClr val="2C3E50"/>
                 </a:solidFill>
               </a:rPr>
-              <a:t>MDP 호환 유지하면서 10-class 달성</a:t>
-            </a:r>
-          </a:p>
-        </p:txBody>
-      </p:sp>
-      <p:sp>
-        <p:nvSpPr>
-          <p:cNvPr id="21" name="Rectangle 20"/>
+              <a:t>pitcher arsenal / cluster / UMAP context feature 생성</a:t>
+            </a:r>
+          </a:p>
+        </p:txBody>
+      </p:sp>
+      <p:sp>
+        <p:nvSpPr>
+          <p:cNvPr id="16" name="Rectangle 15"/>
           <p:cNvSpPr/>
           <p:nvPr/>
         </p:nvSpPr>
         <p:spPr>
           <a:xfrm>
-            <a:off x="3456000" y="2411999"/>
-            <a:ext cx="1404000" cy="324000"/>
+            <a:off x="8621965" y="2116798"/>
+            <a:ext cx="3134986" cy="259200"/>
           </a:xfrm>
           <a:prstGeom prst="rect">
             <a:avLst/>
           </a:prstGeom>
           <a:solidFill>
-            <a:srgbClr val="EBF5FB"/>
+            <a:srgbClr val="F8F9FA"/>
           </a:solidFill>
-          <a:ln w="19050">
-            <a:solidFill>
-              <a:srgbClr val="2980B9"/>
-            </a:solidFill>
+          <a:ln>
+            <a:noFill/>
           </a:ln>
         </p:spPr>
         <p:style>
@@ -5172,14 +4930,14 @@
       </p:sp>
       <p:sp>
         <p:nvSpPr>
-          <p:cNvPr id="22" name="TextBox 21"/>
-          <p:cNvSpPr txBox="1"/>
-          <p:nvPr/>
-        </p:nvSpPr>
-        <p:spPr>
-          <a:xfrm>
-            <a:off x="3528000" y="2419200"/>
-            <a:ext cx="1260000" cy="151200"/>
+          <p:cNvPr id="17" name="TextBox 16"/>
+          <p:cNvSpPr txBox="1"/>
+          <p:nvPr/>
+        </p:nvSpPr>
+        <p:spPr>
+          <a:xfrm>
+            <a:off x="8675965" y="2159998"/>
+            <a:ext cx="3026986" cy="223200"/>
           </a:xfrm>
           <a:prstGeom prst="rect">
             <a:avLst/>
@@ -5194,13 +4952,210 @@
           <a:p>
             <a:pPr algn="l"/>
             <a:r>
-              <a:rPr sz="1200" b="1">
+              <a:rPr sz="1050" b="1">
+                <a:solidFill>
+                  <a:srgbClr val="95A5A6"/>
+                </a:solidFill>
+              </a:rPr>
+              <a:t>clustering 팀</a:t>
+            </a:r>
+          </a:p>
+        </p:txBody>
+      </p:sp>
+      <p:sp>
+        <p:nvSpPr>
+          <p:cNvPr id="18" name="Rectangle 17"/>
+          <p:cNvSpPr/>
+          <p:nvPr/>
+        </p:nvSpPr>
+        <p:spPr>
+          <a:xfrm>
+            <a:off x="432000" y="2397598"/>
+            <a:ext cx="8153965" cy="259200"/>
+          </a:xfrm>
+          <a:prstGeom prst="rect">
+            <a:avLst/>
+          </a:prstGeom>
+          <a:solidFill>
+            <a:srgbClr val="EBF5FB"/>
+          </a:solidFill>
+          <a:ln>
+            <a:noFill/>
+          </a:ln>
+        </p:spPr>
+        <p:style>
+          <a:lnRef idx="1">
+            <a:schemeClr val="accent1"/>
+          </a:lnRef>
+          <a:fillRef idx="3">
+            <a:schemeClr val="accent1"/>
+          </a:fillRef>
+          <a:effectRef idx="2">
+            <a:schemeClr val="accent1"/>
+          </a:effectRef>
+          <a:fontRef idx="minor">
+            <a:schemeClr val="lt1"/>
+          </a:fontRef>
+        </p:style>
+        <p:txBody>
+          <a:bodyPr rtlCol="0" anchor="ctr"/>
+          <a:lstStyle/>
+          <a:p>
+            <a:pPr algn="ctr"/>
+          </a:p>
+        </p:txBody>
+      </p:sp>
+      <p:sp>
+        <p:nvSpPr>
+          <p:cNvPr id="19" name="TextBox 18"/>
+          <p:cNvSpPr txBox="1"/>
+          <p:nvPr/>
+        </p:nvSpPr>
+        <p:spPr>
+          <a:xfrm>
+            <a:off x="504000" y="2440798"/>
+            <a:ext cx="8009965" cy="223200"/>
+          </a:xfrm>
+          <a:prstGeom prst="rect">
+            <a:avLst/>
+          </a:prstGeom>
+          <a:noFill/>
+        </p:spPr>
+        <p:txBody>
+          <a:bodyPr wrap="square">
+            <a:spAutoFit/>
+          </a:bodyPr>
+          <a:lstStyle/>
+          <a:p>
+            <a:pPr algn="l"/>
+            <a:r>
+              <a:rPr sz="1050" b="1">
+                <a:solidFill>
+                  <a:srgbClr val="2C3E50"/>
+                </a:solidFill>
+              </a:rPr>
+              <a:t>그 context를 77d에 붙여 135d 입력으로 통합</a:t>
+            </a:r>
+          </a:p>
+        </p:txBody>
+      </p:sp>
+      <p:sp>
+        <p:nvSpPr>
+          <p:cNvPr id="20" name="Rectangle 19"/>
+          <p:cNvSpPr/>
+          <p:nvPr/>
+        </p:nvSpPr>
+        <p:spPr>
+          <a:xfrm>
+            <a:off x="8621965" y="2397598"/>
+            <a:ext cx="3134986" cy="259200"/>
+          </a:xfrm>
+          <a:prstGeom prst="rect">
+            <a:avLst/>
+          </a:prstGeom>
+          <a:solidFill>
+            <a:srgbClr val="EBF5FB"/>
+          </a:solidFill>
+          <a:ln>
+            <a:noFill/>
+          </a:ln>
+        </p:spPr>
+        <p:style>
+          <a:lnRef idx="1">
+            <a:schemeClr val="accent1"/>
+          </a:lnRef>
+          <a:fillRef idx="3">
+            <a:schemeClr val="accent1"/>
+          </a:fillRef>
+          <a:effectRef idx="2">
+            <a:schemeClr val="accent1"/>
+          </a:effectRef>
+          <a:fontRef idx="minor">
+            <a:schemeClr val="lt1"/>
+          </a:fontRef>
+        </p:style>
+        <p:txBody>
+          <a:bodyPr rtlCol="0" anchor="ctr"/>
+          <a:lstStyle/>
+          <a:p>
+            <a:pPr algn="ctr"/>
+          </a:p>
+        </p:txBody>
+      </p:sp>
+      <p:sp>
+        <p:nvSpPr>
+          <p:cNvPr id="21" name="TextBox 20"/>
+          <p:cNvSpPr txBox="1"/>
+          <p:nvPr/>
+        </p:nvSpPr>
+        <p:spPr>
+          <a:xfrm>
+            <a:off x="8675965" y="2440798"/>
+            <a:ext cx="3026986" cy="223200"/>
+          </a:xfrm>
+          <a:prstGeom prst="rect">
+            <a:avLst/>
+          </a:prstGeom>
+          <a:noFill/>
+        </p:spPr>
+        <p:txBody>
+          <a:bodyPr wrap="square">
+            <a:spAutoFit/>
+          </a:bodyPr>
+          <a:lstStyle/>
+          <a:p>
+            <a:pPr algn="l"/>
+            <a:r>
+              <a:rPr sz="1050" b="1">
                 <a:solidFill>
                   <a:srgbClr val="2980B9"/>
                 </a:solidFill>
               </a:rPr>
-              <a:t>③ Collapse 규명</a:t>
-            </a:r>
+              <a:t>transition-models</a:t>
+            </a:r>
+          </a:p>
+        </p:txBody>
+      </p:sp>
+      <p:sp>
+        <p:nvSpPr>
+          <p:cNvPr id="22" name="Rectangle 21"/>
+          <p:cNvSpPr/>
+          <p:nvPr/>
+        </p:nvSpPr>
+        <p:spPr>
+          <a:xfrm>
+            <a:off x="432000" y="2678398"/>
+            <a:ext cx="8153965" cy="259200"/>
+          </a:xfrm>
+          <a:prstGeom prst="rect">
+            <a:avLst/>
+          </a:prstGeom>
+          <a:solidFill>
+            <a:srgbClr val="EBF5FB"/>
+          </a:solidFill>
+          <a:ln>
+            <a:noFill/>
+          </a:ln>
+        </p:spPr>
+        <p:style>
+          <a:lnRef idx="1">
+            <a:schemeClr val="accent1"/>
+          </a:lnRef>
+          <a:fillRef idx="3">
+            <a:schemeClr val="accent1"/>
+          </a:fillRef>
+          <a:effectRef idx="2">
+            <a:schemeClr val="accent1"/>
+          </a:effectRef>
+          <a:fontRef idx="minor">
+            <a:schemeClr val="lt1"/>
+          </a:fontRef>
+        </p:style>
+        <p:txBody>
+          <a:bodyPr rtlCol="0" anchor="ctr"/>
+          <a:lstStyle/>
+          <a:p>
+            <a:pPr algn="ctr"/>
           </a:p>
         </p:txBody>
       </p:sp>
@@ -5212,8 +5167,8 @@
         </p:nvSpPr>
         <p:spPr>
           <a:xfrm>
-            <a:off x="3528000" y="2573999"/>
-            <a:ext cx="1260000" cy="162000"/>
+            <a:off x="504000" y="2721598"/>
+            <a:ext cx="8009965" cy="223200"/>
           </a:xfrm>
           <a:prstGeom prst="rect">
             <a:avLst/>
@@ -5228,12 +5183,585 @@
           <a:p>
             <a:pPr algn="l"/>
             <a:r>
-              <a:rPr sz="950" b="0">
+              <a:rPr sz="1050" b="1">
                 <a:solidFill>
                   <a:srgbClr val="2C3E50"/>
                 </a:solidFill>
               </a:rPr>
-              <a:t>원인 분석 및 해결</a:t>
+              <a:t>논문 모델(Otremba/MIT Sloan) 재현 + 학습/평가</a:t>
+            </a:r>
+          </a:p>
+        </p:txBody>
+      </p:sp>
+      <p:sp>
+        <p:nvSpPr>
+          <p:cNvPr id="24" name="Rectangle 23"/>
+          <p:cNvSpPr/>
+          <p:nvPr/>
+        </p:nvSpPr>
+        <p:spPr>
+          <a:xfrm>
+            <a:off x="8621965" y="2678398"/>
+            <a:ext cx="3134986" cy="259200"/>
+          </a:xfrm>
+          <a:prstGeom prst="rect">
+            <a:avLst/>
+          </a:prstGeom>
+          <a:solidFill>
+            <a:srgbClr val="EBF5FB"/>
+          </a:solidFill>
+          <a:ln>
+            <a:noFill/>
+          </a:ln>
+        </p:spPr>
+        <p:style>
+          <a:lnRef idx="1">
+            <a:schemeClr val="accent1"/>
+          </a:lnRef>
+          <a:fillRef idx="3">
+            <a:schemeClr val="accent1"/>
+          </a:fillRef>
+          <a:effectRef idx="2">
+            <a:schemeClr val="accent1"/>
+          </a:effectRef>
+          <a:fontRef idx="minor">
+            <a:schemeClr val="lt1"/>
+          </a:fontRef>
+        </p:style>
+        <p:txBody>
+          <a:bodyPr rtlCol="0" anchor="ctr"/>
+          <a:lstStyle/>
+          <a:p>
+            <a:pPr algn="ctr"/>
+          </a:p>
+        </p:txBody>
+      </p:sp>
+      <p:sp>
+        <p:nvSpPr>
+          <p:cNvPr id="25" name="TextBox 24"/>
+          <p:cNvSpPr txBox="1"/>
+          <p:nvPr/>
+        </p:nvSpPr>
+        <p:spPr>
+          <a:xfrm>
+            <a:off x="8675965" y="2721598"/>
+            <a:ext cx="3026986" cy="223200"/>
+          </a:xfrm>
+          <a:prstGeom prst="rect">
+            <a:avLst/>
+          </a:prstGeom>
+          <a:noFill/>
+        </p:spPr>
+        <p:txBody>
+          <a:bodyPr wrap="square">
+            <a:spAutoFit/>
+          </a:bodyPr>
+          <a:lstStyle/>
+          <a:p>
+            <a:pPr algn="l"/>
+            <a:r>
+              <a:rPr sz="1050" b="1">
+                <a:solidFill>
+                  <a:srgbClr val="2980B9"/>
+                </a:solidFill>
+              </a:rPr>
+              <a:t>transition-models</a:t>
+            </a:r>
+          </a:p>
+        </p:txBody>
+      </p:sp>
+      <p:sp>
+        <p:nvSpPr>
+          <p:cNvPr id="26" name="Rectangle 25"/>
+          <p:cNvSpPr/>
+          <p:nvPr/>
+        </p:nvSpPr>
+        <p:spPr>
+          <a:xfrm>
+            <a:off x="432000" y="2959198"/>
+            <a:ext cx="8153965" cy="259200"/>
+          </a:xfrm>
+          <a:prstGeom prst="rect">
+            <a:avLst/>
+          </a:prstGeom>
+          <a:solidFill>
+            <a:srgbClr val="EBF5FB"/>
+          </a:solidFill>
+          <a:ln>
+            <a:noFill/>
+          </a:ln>
+        </p:spPr>
+        <p:style>
+          <a:lnRef idx="1">
+            <a:schemeClr val="accent1"/>
+          </a:lnRef>
+          <a:fillRef idx="3">
+            <a:schemeClr val="accent1"/>
+          </a:fillRef>
+          <a:effectRef idx="2">
+            <a:schemeClr val="accent1"/>
+          </a:effectRef>
+          <a:fontRef idx="minor">
+            <a:schemeClr val="lt1"/>
+          </a:fontRef>
+        </p:style>
+        <p:txBody>
+          <a:bodyPr rtlCol="0" anchor="ctr"/>
+          <a:lstStyle/>
+          <a:p>
+            <a:pPr algn="ctr"/>
+          </a:p>
+        </p:txBody>
+      </p:sp>
+      <p:sp>
+        <p:nvSpPr>
+          <p:cNvPr id="27" name="TextBox 26"/>
+          <p:cNvSpPr txBox="1"/>
+          <p:nvPr/>
+        </p:nvSpPr>
+        <p:spPr>
+          <a:xfrm>
+            <a:off x="504000" y="3002398"/>
+            <a:ext cx="8009965" cy="223200"/>
+          </a:xfrm>
+          <a:prstGeom prst="rect">
+            <a:avLst/>
+          </a:prstGeom>
+          <a:noFill/>
+        </p:spPr>
+        <p:txBody>
+          <a:bodyPr wrap="square">
+            <a:spAutoFit/>
+          </a:bodyPr>
+          <a:lstStyle/>
+          <a:p>
+            <a:pPr algn="l"/>
+            <a:r>
+              <a:rPr sz="1050" b="1">
+                <a:solidFill>
+                  <a:srgbClr val="2C3E50"/>
+                </a:solidFill>
+              </a:rPr>
+              <a:t>77d collapse vs 135d 개선 검증 · 12모델 공정 비교</a:t>
+            </a:r>
+          </a:p>
+        </p:txBody>
+      </p:sp>
+      <p:sp>
+        <p:nvSpPr>
+          <p:cNvPr id="28" name="Rectangle 27"/>
+          <p:cNvSpPr/>
+          <p:nvPr/>
+        </p:nvSpPr>
+        <p:spPr>
+          <a:xfrm>
+            <a:off x="8621965" y="2959198"/>
+            <a:ext cx="3134986" cy="259200"/>
+          </a:xfrm>
+          <a:prstGeom prst="rect">
+            <a:avLst/>
+          </a:prstGeom>
+          <a:solidFill>
+            <a:srgbClr val="EBF5FB"/>
+          </a:solidFill>
+          <a:ln>
+            <a:noFill/>
+          </a:ln>
+        </p:spPr>
+        <p:style>
+          <a:lnRef idx="1">
+            <a:schemeClr val="accent1"/>
+          </a:lnRef>
+          <a:fillRef idx="3">
+            <a:schemeClr val="accent1"/>
+          </a:fillRef>
+          <a:effectRef idx="2">
+            <a:schemeClr val="accent1"/>
+          </a:effectRef>
+          <a:fontRef idx="minor">
+            <a:schemeClr val="lt1"/>
+          </a:fontRef>
+        </p:style>
+        <p:txBody>
+          <a:bodyPr rtlCol="0" anchor="ctr"/>
+          <a:lstStyle/>
+          <a:p>
+            <a:pPr algn="ctr"/>
+          </a:p>
+        </p:txBody>
+      </p:sp>
+      <p:sp>
+        <p:nvSpPr>
+          <p:cNvPr id="29" name="TextBox 28"/>
+          <p:cNvSpPr txBox="1"/>
+          <p:nvPr/>
+        </p:nvSpPr>
+        <p:spPr>
+          <a:xfrm>
+            <a:off x="8675965" y="3002398"/>
+            <a:ext cx="3026986" cy="223200"/>
+          </a:xfrm>
+          <a:prstGeom prst="rect">
+            <a:avLst/>
+          </a:prstGeom>
+          <a:noFill/>
+        </p:spPr>
+        <p:txBody>
+          <a:bodyPr wrap="square">
+            <a:spAutoFit/>
+          </a:bodyPr>
+          <a:lstStyle/>
+          <a:p>
+            <a:pPr algn="l"/>
+            <a:r>
+              <a:rPr sz="1050" b="1">
+                <a:solidFill>
+                  <a:srgbClr val="2980B9"/>
+                </a:solidFill>
+              </a:rPr>
+              <a:t>transition-models</a:t>
+            </a:r>
+          </a:p>
+        </p:txBody>
+      </p:sp>
+      <p:sp>
+        <p:nvSpPr>
+          <p:cNvPr id="30" name="Rectangle 29"/>
+          <p:cNvSpPr/>
+          <p:nvPr/>
+        </p:nvSpPr>
+        <p:spPr>
+          <a:xfrm>
+            <a:off x="432000" y="3239998"/>
+            <a:ext cx="8153965" cy="259200"/>
+          </a:xfrm>
+          <a:prstGeom prst="rect">
+            <a:avLst/>
+          </a:prstGeom>
+          <a:solidFill>
+            <a:srgbClr val="EBF5FB"/>
+          </a:solidFill>
+          <a:ln>
+            <a:noFill/>
+          </a:ln>
+        </p:spPr>
+        <p:style>
+          <a:lnRef idx="1">
+            <a:schemeClr val="accent1"/>
+          </a:lnRef>
+          <a:fillRef idx="3">
+            <a:schemeClr val="accent1"/>
+          </a:fillRef>
+          <a:effectRef idx="2">
+            <a:schemeClr val="accent1"/>
+          </a:effectRef>
+          <a:fontRef idx="minor">
+            <a:schemeClr val="lt1"/>
+          </a:fontRef>
+        </p:style>
+        <p:txBody>
+          <a:bodyPr rtlCol="0" anchor="ctr"/>
+          <a:lstStyle/>
+          <a:p>
+            <a:pPr algn="ctr"/>
+          </a:p>
+        </p:txBody>
+      </p:sp>
+      <p:sp>
+        <p:nvSpPr>
+          <p:cNvPr id="31" name="TextBox 30"/>
+          <p:cNvSpPr txBox="1"/>
+          <p:nvPr/>
+        </p:nvSpPr>
+        <p:spPr>
+          <a:xfrm>
+            <a:off x="504000" y="3283198"/>
+            <a:ext cx="8009965" cy="223200"/>
+          </a:xfrm>
+          <a:prstGeom prst="rect">
+            <a:avLst/>
+          </a:prstGeom>
+          <a:noFill/>
+        </p:spPr>
+        <p:txBody>
+          <a:bodyPr wrap="square">
+            <a:spAutoFit/>
+          </a:bodyPr>
+          <a:lstStyle/>
+          <a:p>
+            <a:pPr algn="l"/>
+            <a:r>
+              <a:rPr sz="1050" b="1">
+                <a:solidFill>
+                  <a:srgbClr val="2C3E50"/>
+                </a:solidFill>
+              </a:rPr>
+              <a:t>rl-agent용 inference wrapper / handoff 문서</a:t>
+            </a:r>
+          </a:p>
+        </p:txBody>
+      </p:sp>
+      <p:sp>
+        <p:nvSpPr>
+          <p:cNvPr id="32" name="Rectangle 31"/>
+          <p:cNvSpPr/>
+          <p:nvPr/>
+        </p:nvSpPr>
+        <p:spPr>
+          <a:xfrm>
+            <a:off x="8621965" y="3239998"/>
+            <a:ext cx="3134986" cy="259200"/>
+          </a:xfrm>
+          <a:prstGeom prst="rect">
+            <a:avLst/>
+          </a:prstGeom>
+          <a:solidFill>
+            <a:srgbClr val="EBF5FB"/>
+          </a:solidFill>
+          <a:ln>
+            <a:noFill/>
+          </a:ln>
+        </p:spPr>
+        <p:style>
+          <a:lnRef idx="1">
+            <a:schemeClr val="accent1"/>
+          </a:lnRef>
+          <a:fillRef idx="3">
+            <a:schemeClr val="accent1"/>
+          </a:fillRef>
+          <a:effectRef idx="2">
+            <a:schemeClr val="accent1"/>
+          </a:effectRef>
+          <a:fontRef idx="minor">
+            <a:schemeClr val="lt1"/>
+          </a:fontRef>
+        </p:style>
+        <p:txBody>
+          <a:bodyPr rtlCol="0" anchor="ctr"/>
+          <a:lstStyle/>
+          <a:p>
+            <a:pPr algn="ctr"/>
+          </a:p>
+        </p:txBody>
+      </p:sp>
+      <p:sp>
+        <p:nvSpPr>
+          <p:cNvPr id="33" name="TextBox 32"/>
+          <p:cNvSpPr txBox="1"/>
+          <p:nvPr/>
+        </p:nvSpPr>
+        <p:spPr>
+          <a:xfrm>
+            <a:off x="8675965" y="3283198"/>
+            <a:ext cx="3026986" cy="223200"/>
+          </a:xfrm>
+          <a:prstGeom prst="rect">
+            <a:avLst/>
+          </a:prstGeom>
+          <a:noFill/>
+        </p:spPr>
+        <p:txBody>
+          <a:bodyPr wrap="square">
+            <a:spAutoFit/>
+          </a:bodyPr>
+          <a:lstStyle/>
+          <a:p>
+            <a:pPr algn="l"/>
+            <a:r>
+              <a:rPr sz="1050" b="1">
+                <a:solidFill>
+                  <a:srgbClr val="2980B9"/>
+                </a:solidFill>
+              </a:rPr>
+              <a:t>transition-models</a:t>
+            </a:r>
+          </a:p>
+        </p:txBody>
+      </p:sp>
+      <p:sp>
+        <p:nvSpPr>
+          <p:cNvPr id="34" name="Rectangle 33"/>
+          <p:cNvSpPr/>
+          <p:nvPr/>
+        </p:nvSpPr>
+        <p:spPr>
+          <a:xfrm>
+            <a:off x="432000" y="3520798"/>
+            <a:ext cx="8153965" cy="259200"/>
+          </a:xfrm>
+          <a:prstGeom prst="rect">
+            <a:avLst/>
+          </a:prstGeom>
+          <a:solidFill>
+            <a:srgbClr val="F8F9FA"/>
+          </a:solidFill>
+          <a:ln>
+            <a:noFill/>
+          </a:ln>
+        </p:spPr>
+        <p:style>
+          <a:lnRef idx="1">
+            <a:schemeClr val="accent1"/>
+          </a:lnRef>
+          <a:fillRef idx="3">
+            <a:schemeClr val="accent1"/>
+          </a:fillRef>
+          <a:effectRef idx="2">
+            <a:schemeClr val="accent1"/>
+          </a:effectRef>
+          <a:fontRef idx="minor">
+            <a:schemeClr val="lt1"/>
+          </a:fontRef>
+        </p:style>
+        <p:txBody>
+          <a:bodyPr rtlCol="0" anchor="ctr"/>
+          <a:lstStyle/>
+          <a:p>
+            <a:pPr algn="ctr"/>
+          </a:p>
+        </p:txBody>
+      </p:sp>
+      <p:sp>
+        <p:nvSpPr>
+          <p:cNvPr id="35" name="TextBox 34"/>
+          <p:cNvSpPr txBox="1"/>
+          <p:nvPr/>
+        </p:nvSpPr>
+        <p:spPr>
+          <a:xfrm>
+            <a:off x="504000" y="3563998"/>
+            <a:ext cx="8009965" cy="223200"/>
+          </a:xfrm>
+          <a:prstGeom prst="rect">
+            <a:avLst/>
+          </a:prstGeom>
+          <a:noFill/>
+        </p:spPr>
+        <p:txBody>
+          <a:bodyPr wrap="square">
+            <a:spAutoFit/>
+          </a:bodyPr>
+          <a:lstStyle/>
+          <a:p>
+            <a:pPr algn="l"/>
+            <a:r>
+              <a:rPr sz="1050" b="0">
+                <a:solidFill>
+                  <a:srgbClr val="2C3E50"/>
+                </a:solidFill>
+              </a:rPr>
+              <a:t>MLP10H BIP 보정 (보상 왜곡 완화)</a:t>
+            </a:r>
+          </a:p>
+        </p:txBody>
+      </p:sp>
+      <p:sp>
+        <p:nvSpPr>
+          <p:cNvPr id="36" name="Rectangle 35"/>
+          <p:cNvSpPr/>
+          <p:nvPr/>
+        </p:nvSpPr>
+        <p:spPr>
+          <a:xfrm>
+            <a:off x="8621965" y="3520798"/>
+            <a:ext cx="3134986" cy="259200"/>
+          </a:xfrm>
+          <a:prstGeom prst="rect">
+            <a:avLst/>
+          </a:prstGeom>
+          <a:solidFill>
+            <a:srgbClr val="F8F9FA"/>
+          </a:solidFill>
+          <a:ln>
+            <a:noFill/>
+          </a:ln>
+        </p:spPr>
+        <p:style>
+          <a:lnRef idx="1">
+            <a:schemeClr val="accent1"/>
+          </a:lnRef>
+          <a:fillRef idx="3">
+            <a:schemeClr val="accent1"/>
+          </a:fillRef>
+          <a:effectRef idx="2">
+            <a:schemeClr val="accent1"/>
+          </a:effectRef>
+          <a:fontRef idx="minor">
+            <a:schemeClr val="lt1"/>
+          </a:fontRef>
+        </p:style>
+        <p:txBody>
+          <a:bodyPr rtlCol="0" anchor="ctr"/>
+          <a:lstStyle/>
+          <a:p>
+            <a:pPr algn="ctr"/>
+          </a:p>
+        </p:txBody>
+      </p:sp>
+      <p:sp>
+        <p:nvSpPr>
+          <p:cNvPr id="37" name="TextBox 36"/>
+          <p:cNvSpPr txBox="1"/>
+          <p:nvPr/>
+        </p:nvSpPr>
+        <p:spPr>
+          <a:xfrm>
+            <a:off x="8675965" y="3563998"/>
+            <a:ext cx="3026986" cy="223200"/>
+          </a:xfrm>
+          <a:prstGeom prst="rect">
+            <a:avLst/>
+          </a:prstGeom>
+          <a:noFill/>
+        </p:spPr>
+        <p:txBody>
+          <a:bodyPr wrap="square">
+            <a:spAutoFit/>
+          </a:bodyPr>
+          <a:lstStyle/>
+          <a:p>
+            <a:pPr algn="l"/>
+            <a:r>
+              <a:rPr sz="1050" b="1">
+                <a:solidFill>
+                  <a:srgbClr val="E67E22"/>
+                </a:solidFill>
+              </a:rPr>
+              <a:t>rl-agent 통합</a:t>
+            </a:r>
+          </a:p>
+        </p:txBody>
+      </p:sp>
+      <p:sp>
+        <p:nvSpPr>
+          <p:cNvPr id="38" name="TextBox 37"/>
+          <p:cNvSpPr txBox="1"/>
+          <p:nvPr/>
+        </p:nvSpPr>
+        <p:spPr>
+          <a:xfrm>
+            <a:off x="432000" y="3837598"/>
+            <a:ext cx="11324952" cy="251999"/>
+          </a:xfrm>
+          <a:prstGeom prst="rect">
+            <a:avLst/>
+          </a:prstGeom>
+          <a:noFill/>
+        </p:spPr>
+        <p:txBody>
+          <a:bodyPr wrap="square">
+            <a:spAutoFit/>
+          </a:bodyPr>
+          <a:lstStyle/>
+          <a:p>
+            <a:pPr algn="l"/>
+            <a:r>
+              <a:rPr sz="1050" b="1">
+                <a:solidFill>
+                  <a:srgbClr val="E67E22"/>
+                </a:solidFill>
+              </a:rPr>
+              <a:t>⚠️ "arsenal feature를 내가 만들었다"가 아니라 → "그 feature가 전이확률 모델 성능을 실제로 개선하는지 검증했다"가 정확</a:t>
             </a:r>
           </a:p>
         </p:txBody>
@@ -5336,7 +5864,7 @@
                   <a:srgbClr val="FFFFFF"/>
                 </a:solidFill>
               </a:rPr>
-              <a:t>논문 포지셔닝: 3-way 비교</a:t>
+              <a:t>초기 접근: 기존 연구 2개를 baseline으로 재현</a:t>
             </a:r>
           </a:p>
         </p:txBody>
@@ -5375,9 +5903,43 @@
           </a:p>
         </p:txBody>
       </p:sp>
+      <p:sp>
+        <p:nvSpPr>
+          <p:cNvPr id="5" name="TextBox 4"/>
+          <p:cNvSpPr txBox="1"/>
+          <p:nvPr/>
+        </p:nvSpPr>
+        <p:spPr>
+          <a:xfrm>
+            <a:off x="432000" y="756000"/>
+            <a:ext cx="11324952" cy="288000"/>
+          </a:xfrm>
+          <a:prstGeom prst="rect">
+            <a:avLst/>
+          </a:prstGeom>
+          <a:noFill/>
+        </p:spPr>
+        <p:txBody>
+          <a:bodyPr wrap="square">
+            <a:spAutoFit/>
+          </a:bodyPr>
+          <a:lstStyle/>
+          <a:p>
+            <a:pPr algn="ctr"/>
+            <a:r>
+              <a:rPr sz="1250" b="1">
+                <a:solidFill>
+                  <a:srgbClr val="2C3E50"/>
+                </a:solidFill>
+              </a:rPr>
+              <a:t>처음엔 후속 RL보다 "투구 결과 확률을 잘 예측하는 모델" 자체에 집중 → 기존 연구를 baseline으로 재현 (새 모델 발명 아님)</a:t>
+            </a:r>
+          </a:p>
+        </p:txBody>
+      </p:sp>
       <p:pic>
         <p:nvPicPr>
-          <p:cNvPr id="5" name="Picture 4" descr="fig2_paper_positioning.png"/>
+          <p:cNvPr id="6" name="Picture 5" descr="fig2_paper_positioning.png"/>
           <p:cNvPicPr>
             <a:picLocks noChangeAspect="1"/>
           </p:cNvPicPr>
@@ -5391,8 +5953,8 @@
         </p:blipFill>
         <p:spPr>
           <a:xfrm>
-            <a:off x="432000" y="756000"/>
-            <a:ext cx="11324952" cy="5355883"/>
+            <a:off x="442448" y="1080000"/>
+            <a:ext cx="11304055" cy="5346000"/>
           </a:xfrm>
           <a:prstGeom prst="rect">
             <a:avLst/>
@@ -5401,7 +5963,7 @@
       </p:pic>
       <p:sp>
         <p:nvSpPr>
-          <p:cNvPr id="6" name="TextBox 5"/>
+          <p:cNvPr id="7" name="TextBox 6"/>
           <p:cNvSpPr txBox="1"/>
           <p:nvPr/>
         </p:nvSpPr>
@@ -5428,7 +5990,7 @@
                   <a:srgbClr val="E67E22"/>
                 </a:solidFill>
               </a:rPr>
-              <a:t>차별점: Otremba MDP/RL 통합  +  MIT Sloan-style 10-class 세분화  +  본인 Arsenal Context 58d</a:t>
+              <a:t>기여: baseline 재현 + 공정 비교 기준 수립 + 상류 clustering context의 전이확률 개선 효과 검증</a:t>
             </a:r>
           </a:p>
         </p:txBody>
@@ -11787,7 +12349,7 @@
                   <a:srgbClr val="FFFFFF"/>
                 </a:solidFill>
               </a:rPr>
-              <a:t>핵심 발견 2: Arsenal Context가 Collapse 해소</a:t>
+              <a:t>핵심 발견 2: 상류 context feature가 Collapse 해소 (효과 검증)</a:t>
             </a:r>
           </a:p>
         </p:txBody>
@@ -13091,7 +13653,7 @@
         <p:spPr>
           <a:xfrm>
             <a:off x="432000" y="3311999"/>
-            <a:ext cx="11324952" cy="324000"/>
+            <a:ext cx="11324952" cy="450000"/>
           </a:xfrm>
           <a:prstGeom prst="rect">
             <a:avLst/>
@@ -13133,8 +13695,8 @@
         </p:nvSpPr>
         <p:spPr>
           <a:xfrm>
-            <a:off x="540000" y="3340799"/>
-            <a:ext cx="11108952" cy="288000"/>
+            <a:off x="540000" y="3347999"/>
+            <a:ext cx="11108952" cy="396000"/>
           </a:xfrm>
           <a:prstGeom prst="rect">
             <a:avLst/>
@@ -13149,13 +13711,13 @@
           <a:p>
             <a:pPr algn="l"/>
             <a:r>
-              <a:rPr sz="1100" b="0">
+              <a:rPr sz="1050" b="0">
                 <a:solidFill>
                   <a:srgbClr val="2980B9"/>
                 </a:solidFill>
               </a:rPr>
-              <a:t>결론: Collapse 원인 = Architecture × Feature 수 아님 = 투수 맥락(pitcher context) 부재
-Top-1은 sequence baseline과 유사, MLP10은 MDP 호환성과 추론 효율이 강점</a:t>
+              <a:t>결론: collapse 원인 = architecture·feature 수 아님 = 투수 맥락(context) 부재 (architecture 무관 +21~54pp)
+⚠️ 기여 = context feature 생성(❌, clustering 팀)이 아니라, 같은 모델·같은 test set 통제 실험으로 그 효과를 검증(✅)한 것</a:t>
             </a:r>
           </a:p>
         </p:txBody>
@@ -13258,7 +13820,7 @@
                   <a:srgbClr val="FFFFFF"/>
                 </a:solidFill>
               </a:rPr>
-              <a:t>Phase 10 최종: 12-model 전체 비교</a:t>
+              <a:t>전이확률 → 장기 보상 → RL handoff (MLP10/MLP10H)</a:t>
             </a:r>
           </a:p>
         </p:txBody>
@@ -13297,9 +13859,120 @@
           </a:p>
         </p:txBody>
       </p:sp>
+      <p:sp>
+        <p:nvSpPr>
+          <p:cNvPr id="5" name="Rectangle 4"/>
+          <p:cNvSpPr/>
+          <p:nvPr/>
+        </p:nvSpPr>
+        <p:spPr>
+          <a:xfrm>
+            <a:off x="432000" y="756000"/>
+            <a:ext cx="11324952" cy="540000"/>
+          </a:xfrm>
+          <a:prstGeom prst="rect">
+            <a:avLst/>
+          </a:prstGeom>
+          <a:solidFill>
+            <a:srgbClr val="F0F4F8"/>
+          </a:solidFill>
+          <a:ln>
+            <a:noFill/>
+          </a:ln>
+        </p:spPr>
+        <p:style>
+          <a:lnRef idx="1">
+            <a:schemeClr val="accent1"/>
+          </a:lnRef>
+          <a:fillRef idx="3">
+            <a:schemeClr val="accent1"/>
+          </a:fillRef>
+          <a:effectRef idx="2">
+            <a:schemeClr val="accent1"/>
+          </a:effectRef>
+          <a:fontRef idx="minor">
+            <a:schemeClr val="lt1"/>
+          </a:fontRef>
+        </p:style>
+        <p:txBody>
+          <a:bodyPr rtlCol="0" anchor="ctr"/>
+          <a:lstStyle/>
+          <a:p>
+            <a:pPr algn="ctr"/>
+          </a:p>
+        </p:txBody>
+      </p:sp>
+      <p:sp>
+        <p:nvSpPr>
+          <p:cNvPr id="6" name="TextBox 5"/>
+          <p:cNvSpPr txBox="1"/>
+          <p:nvPr/>
+        </p:nvSpPr>
+        <p:spPr>
+          <a:xfrm>
+            <a:off x="540000" y="799200"/>
+            <a:ext cx="11108952" cy="216000"/>
+          </a:xfrm>
+          <a:prstGeom prst="rect">
+            <a:avLst/>
+          </a:prstGeom>
+          <a:noFill/>
+        </p:spPr>
+        <p:txBody>
+          <a:bodyPr wrap="square">
+            <a:spAutoFit/>
+          </a:bodyPr>
+          <a:lstStyle/>
+          <a:p>
+            <a:pPr algn="ctr"/>
+            <a:r>
+              <a:rPr sz="1250" b="1">
+                <a:solidFill>
+                  <a:srgbClr val="2C3E50"/>
+                </a:solidFill>
+              </a:rPr>
+              <a:t>Q(s, a) = Σ_outcome  P(outcome | s, a) · [ RE24_reward + γ·V(s′) ]      reward = RE24(before) − RE24(after) − runs</a:t>
+            </a:r>
+          </a:p>
+        </p:txBody>
+      </p:sp>
+      <p:sp>
+        <p:nvSpPr>
+          <p:cNvPr id="7" name="TextBox 6"/>
+          <p:cNvSpPr txBox="1"/>
+          <p:nvPr/>
+        </p:nvSpPr>
+        <p:spPr>
+          <a:xfrm>
+            <a:off x="540000" y="1036800"/>
+            <a:ext cx="11108952" cy="234000"/>
+          </a:xfrm>
+          <a:prstGeom prst="rect">
+            <a:avLst/>
+          </a:prstGeom>
+          <a:noFill/>
+        </p:spPr>
+        <p:txBody>
+          <a:bodyPr wrap="square">
+            <a:spAutoFit/>
+          </a:bodyPr>
+          <a:lstStyle/>
+          <a:p>
+            <a:pPr algn="ctr"/>
+            <a:r>
+              <a:rPr sz="1000" b="0">
+                <a:solidFill>
+                  <a:srgbClr val="2980B9"/>
+                </a:solidFill>
+              </a:rPr>
+              <a:t>함의1: Q는 확률의 가중평균 → Top-1보다 확률 보정(CE/Brier)이 핵심   |   함의2: RNN/Transformer는 P(·|history,s,a) → 모든 (s,a) 전이표화 어려움 → MDP엔 단일-step iid 모델이 적합</a:t>
+            </a:r>
+          </a:p>
+        </p:txBody>
+      </p:sp>
       <p:pic>
         <p:nvPicPr>
-          <p:cNvPr id="5" name="Picture 4" descr="fig3_phase10_12model.png"/>
+          <p:cNvPr id="8" name="Picture 7" descr="fig3_phase10_12model.png"/>
           <p:cNvPicPr>
             <a:picLocks noChangeAspect="1"/>
           </p:cNvPicPr>
@@ -13313,8 +13986,8 @@
         </p:blipFill>
         <p:spPr>
           <a:xfrm>
-            <a:off x="3793906" y="756000"/>
-            <a:ext cx="4601140" cy="1655999"/>
+            <a:off x="4244016" y="1368000"/>
+            <a:ext cx="3700919" cy="1332000"/>
           </a:xfrm>
           <a:prstGeom prst="rect">
             <a:avLst/>
@@ -13323,14 +13996,14 @@
       </p:pic>
       <p:sp>
         <p:nvSpPr>
-          <p:cNvPr id="6" name="Rectangle 5"/>
+          <p:cNvPr id="9" name="Rectangle 8"/>
           <p:cNvSpPr/>
           <p:nvPr/>
         </p:nvSpPr>
         <p:spPr>
           <a:xfrm>
-            <a:off x="432000" y="2484000"/>
-            <a:ext cx="11324952" cy="576000"/>
+            <a:off x="432000" y="2736000"/>
+            <a:ext cx="11324952" cy="720000"/>
           </a:xfrm>
           <a:prstGeom prst="rect">
             <a:avLst/>
@@ -13368,14 +14041,14 @@
       </p:sp>
       <p:sp>
         <p:nvSpPr>
-          <p:cNvPr id="7" name="TextBox 6"/>
-          <p:cNvSpPr txBox="1"/>
-          <p:nvPr/>
-        </p:nvSpPr>
-        <p:spPr>
-          <a:xfrm>
-            <a:off x="540000" y="2512800"/>
-            <a:ext cx="2880000" cy="198000"/>
+          <p:cNvPr id="10" name="TextBox 9"/>
+          <p:cNvSpPr txBox="1"/>
+          <p:nvPr/>
+        </p:nvSpPr>
+        <p:spPr>
+          <a:xfrm>
+            <a:off x="540000" y="2764800"/>
+            <a:ext cx="11108952" cy="180000"/>
           </a:xfrm>
           <a:prstGeom prst="rect">
             <a:avLst/>
@@ -13390,26 +14063,26 @@
           <a:p>
             <a:pPr algn="l"/>
             <a:r>
-              <a:rPr sz="1400" b="1">
+              <a:rPr sz="1250" b="1">
                 <a:solidFill>
                   <a:srgbClr val="27AE60"/>
                 </a:solidFill>
               </a:rPr>
-              <a:t>✅ 최종 모델: TransitionModelMLP10 / RL 권장 경로: MLP10H</a:t>
-            </a:r>
-          </a:p>
-        </p:txBody>
-      </p:sp>
-      <p:sp>
-        <p:nvSpPr>
-          <p:cNvPr id="8" name="TextBox 7"/>
-          <p:cNvSpPr txBox="1"/>
-          <p:nvPr/>
-        </p:nvSpPr>
-        <p:spPr>
-          <a:xfrm>
-            <a:off x="540000" y="2718000"/>
-            <a:ext cx="11108952" cy="324000"/>
+              <a:t>RL handoff 후보 (MLP10이 '더 좋아서'가 아니라 MDP 전이함수 형태에 맞아서)</a:t>
+            </a:r>
+          </a:p>
+        </p:txBody>
+      </p:sp>
+      <p:sp>
+        <p:nvSpPr>
+          <p:cNvPr id="11" name="TextBox 10"/>
+          <p:cNvSpPr txBox="1"/>
+          <p:nvPr/>
+        </p:nvSpPr>
+        <p:spPr>
+          <a:xfrm>
+            <a:off x="540000" y="2959200"/>
+            <a:ext cx="11108952" cy="468000"/>
           </a:xfrm>
           <a:prstGeom prst="rect">
             <a:avLst/>
@@ -13429,8 +14102,9 @@
                   <a:srgbClr val="2C3E50"/>
                 </a:solidFill>
               </a:rPr>
-              <a:t>MLP10: 135d 단일 pitch, Top-1 67.6%, Macro-F1 27.8%, CE 0.926, MDP 호환
-MLP10H: MLP10의 BIP 총량을 empirical BIP table로 재분배해 Single~HR 0% 문제 완화</a:t>
+              <a:t>MLP10  : 135d 단일-step, Top-1 67.6%, Walk/K/HBP 직접 예측 — 단 Single~HR ≈ 0% → Q가 장타 위험을 0으로 봄(보상 왜곡)
+MLP10H : 빈 BIP 질량을 empirical BIP table로 재분배해 왜곡 완화 (rl-agent 통합 측 보정)
+→ 최종 RL 비교는 같은 환경에서 Model B vs MLP10 vs MLP10H 의 mean reward / per-class 현실성으로 평가</a:t>
             </a:r>
           </a:p>
         </p:txBody>

</xml_diff>